<commit_message>
fix: final script updates
</commit_message>
<xml_diff>
--- a/presentation/warden.pptx
+++ b/presentation/warden.pptx
@@ -5,24 +5,25 @@
     <p:sldMasterId id="2147483648" r:id="rId1"/>
   </p:sldMasterIdLst>
   <p:sldIdLst>
-    <p:sldId id="256" r:id="rId7"/>
-    <p:sldId id="257" r:id="rId8"/>
-    <p:sldId id="258" r:id="rId9"/>
-    <p:sldId id="259" r:id="rId10"/>
-    <p:sldId id="260" r:id="rId11"/>
-    <p:sldId id="261" r:id="rId12"/>
-    <p:sldId id="262" r:id="rId13"/>
-    <p:sldId id="263" r:id="rId14"/>
-    <p:sldId id="264" r:id="rId15"/>
-    <p:sldId id="265" r:id="rId16"/>
-    <p:sldId id="266" r:id="rId17"/>
-    <p:sldId id="267" r:id="rId18"/>
-    <p:sldId id="268" r:id="rId19"/>
-    <p:sldId id="269" r:id="rId20"/>
-    <p:sldId id="270" r:id="rId21"/>
-    <p:sldId id="271" r:id="rId22"/>
+    <p:sldId id="256" r:id="rId2"/>
+    <p:sldId id="257" r:id="rId3"/>
+    <p:sldId id="258" r:id="rId4"/>
+    <p:sldId id="259" r:id="rId5"/>
+    <p:sldId id="260" r:id="rId6"/>
+    <p:sldId id="261" r:id="rId7"/>
+    <p:sldId id="262" r:id="rId8"/>
+    <p:sldId id="263" r:id="rId9"/>
+    <p:sldId id="264" r:id="rId10"/>
+    <p:sldId id="265" r:id="rId11"/>
+    <p:sldId id="266" r:id="rId12"/>
+    <p:sldId id="267" r:id="rId13"/>
+    <p:sldId id="268" r:id="rId14"/>
+    <p:sldId id="269" r:id="rId15"/>
+    <p:sldId id="270" r:id="rId16"/>
+    <p:sldId id="271" r:id="rId17"/>
+    <p:sldId id="272" r:id="rId18"/>
   </p:sldIdLst>
-  <p:sldSz cx="12188952" cy="6858000" type="screen4x3"/>
+  <p:sldSz cx="12188825" cy="6858000"/>
   <p:notesSz cx="6858000" cy="9144000"/>
   <p:defaultTextStyle>
     <a:defPPr>
@@ -119,6 +120,22 @@
       </a:defRPr>
     </a:lvl9pPr>
   </p:defaultTextStyle>
+  <p:extLst>
+    <p:ext uri="{EFAFB233-063F-42B5-8137-9DF3F51BA10A}">
+      <p15:sldGuideLst xmlns:p15="http://schemas.microsoft.com/office/powerpoint/2012/main">
+        <p15:guide id="1" orient="horz" pos="2160">
+          <p15:clr>
+            <a:srgbClr val="A4A3A4"/>
+          </p15:clr>
+        </p15:guide>
+        <p15:guide id="2" pos="2880">
+          <p15:clr>
+            <a:srgbClr val="A4A3A4"/>
+          </p15:clr>
+        </p15:guide>
+      </p15:sldGuideLst>
+    </p:ext>
+  </p:extLst>
 </p:presentation>
 </file>
 
@@ -160,10 +177,9 @@
           <a:lstStyle/>
           <a:p>
             <a:r>
-              <a:rPr lang="en-US" smtClean="0"/>
+              <a:rPr lang="en-US"/>
               <a:t>Click to edit Master title style</a:t>
             </a:r>
-            <a:endParaRPr lang="en-US"/>
           </a:p>
         </p:txBody>
       </p:sp>
@@ -279,10 +295,9 @@
           </a:lstStyle>
           <a:p>
             <a:r>
-              <a:rPr lang="en-US" smtClean="0"/>
+              <a:rPr lang="en-US"/>
               <a:t>Click to edit Master subtitle style</a:t>
             </a:r>
-            <a:endParaRPr lang="en-US"/>
           </a:p>
         </p:txBody>
       </p:sp>
@@ -303,7 +318,7 @@
           <a:p>
             <a:fld id="{5BCAD085-E8A6-8845-BD4E-CB4CCA059FC4}" type="datetimeFigureOut">
               <a:rPr lang="en-US" smtClean="0"/>
-              <a:t>1/27/13</a:t>
+              <a:t>8/6/2026</a:t>
             </a:fld>
             <a:endParaRPr lang="en-US"/>
           </a:p>
@@ -397,10 +412,9 @@
           <a:lstStyle/>
           <a:p>
             <a:r>
-              <a:rPr lang="en-US" smtClean="0"/>
+              <a:rPr lang="en-US"/>
               <a:t>Click to edit Master title style</a:t>
             </a:r>
-            <a:endParaRPr lang="en-US"/>
           </a:p>
         </p:txBody>
       </p:sp>
@@ -421,38 +435,37 @@
           <a:p>
             <a:pPr lvl="0"/>
             <a:r>
-              <a:rPr lang="en-US" smtClean="0"/>
+              <a:rPr lang="en-US"/>
               <a:t>Click to edit Master text styles</a:t>
             </a:r>
           </a:p>
           <a:p>
             <a:pPr lvl="1"/>
             <a:r>
-              <a:rPr lang="en-US" smtClean="0"/>
+              <a:rPr lang="en-US"/>
               <a:t>Second level</a:t>
             </a:r>
           </a:p>
           <a:p>
             <a:pPr lvl="2"/>
             <a:r>
-              <a:rPr lang="en-US" smtClean="0"/>
+              <a:rPr lang="en-US"/>
               <a:t>Third level</a:t>
             </a:r>
           </a:p>
           <a:p>
             <a:pPr lvl="3"/>
             <a:r>
-              <a:rPr lang="en-US" smtClean="0"/>
+              <a:rPr lang="en-US"/>
               <a:t>Fourth level</a:t>
             </a:r>
           </a:p>
           <a:p>
             <a:pPr lvl="4"/>
             <a:r>
-              <a:rPr lang="en-US" smtClean="0"/>
+              <a:rPr lang="en-US"/>
               <a:t>Fifth level</a:t>
             </a:r>
-            <a:endParaRPr lang="en-US"/>
           </a:p>
         </p:txBody>
       </p:sp>
@@ -473,7 +486,7 @@
           <a:p>
             <a:fld id="{5BCAD085-E8A6-8845-BD4E-CB4CCA059FC4}" type="datetimeFigureOut">
               <a:rPr lang="en-US" smtClean="0"/>
-              <a:t>1/27/13</a:t>
+              <a:t>8/6/2026</a:t>
             </a:fld>
             <a:endParaRPr lang="en-US"/>
           </a:p>
@@ -572,10 +585,9 @@
           <a:lstStyle/>
           <a:p>
             <a:r>
-              <a:rPr lang="en-US" smtClean="0"/>
+              <a:rPr lang="en-US"/>
               <a:t>Click to edit Master title style</a:t>
             </a:r>
-            <a:endParaRPr lang="en-US"/>
           </a:p>
         </p:txBody>
       </p:sp>
@@ -601,38 +613,37 @@
           <a:p>
             <a:pPr lvl="0"/>
             <a:r>
-              <a:rPr lang="en-US" smtClean="0"/>
+              <a:rPr lang="en-US"/>
               <a:t>Click to edit Master text styles</a:t>
             </a:r>
           </a:p>
           <a:p>
             <a:pPr lvl="1"/>
             <a:r>
-              <a:rPr lang="en-US" smtClean="0"/>
+              <a:rPr lang="en-US"/>
               <a:t>Second level</a:t>
             </a:r>
           </a:p>
           <a:p>
             <a:pPr lvl="2"/>
             <a:r>
-              <a:rPr lang="en-US" smtClean="0"/>
+              <a:rPr lang="en-US"/>
               <a:t>Third level</a:t>
             </a:r>
           </a:p>
           <a:p>
             <a:pPr lvl="3"/>
             <a:r>
-              <a:rPr lang="en-US" smtClean="0"/>
+              <a:rPr lang="en-US"/>
               <a:t>Fourth level</a:t>
             </a:r>
           </a:p>
           <a:p>
             <a:pPr lvl="4"/>
             <a:r>
-              <a:rPr lang="en-US" smtClean="0"/>
+              <a:rPr lang="en-US"/>
               <a:t>Fifth level</a:t>
             </a:r>
-            <a:endParaRPr lang="en-US"/>
           </a:p>
         </p:txBody>
       </p:sp>
@@ -653,7 +664,7 @@
           <a:p>
             <a:fld id="{5BCAD085-E8A6-8845-BD4E-CB4CCA059FC4}" type="datetimeFigureOut">
               <a:rPr lang="en-US" smtClean="0"/>
-              <a:t>1/27/13</a:t>
+              <a:t>8/6/2026</a:t>
             </a:fld>
             <a:endParaRPr lang="en-US"/>
           </a:p>
@@ -747,10 +758,9 @@
           <a:lstStyle/>
           <a:p>
             <a:r>
-              <a:rPr lang="en-US" smtClean="0"/>
+              <a:rPr lang="en-US"/>
               <a:t>Click to edit Master title style</a:t>
             </a:r>
-            <a:endParaRPr lang="en-US"/>
           </a:p>
         </p:txBody>
       </p:sp>
@@ -771,38 +781,37 @@
           <a:p>
             <a:pPr lvl="0"/>
             <a:r>
-              <a:rPr lang="en-US" smtClean="0"/>
+              <a:rPr lang="en-US"/>
               <a:t>Click to edit Master text styles</a:t>
             </a:r>
           </a:p>
           <a:p>
             <a:pPr lvl="1"/>
             <a:r>
-              <a:rPr lang="en-US" smtClean="0"/>
+              <a:rPr lang="en-US"/>
               <a:t>Second level</a:t>
             </a:r>
           </a:p>
           <a:p>
             <a:pPr lvl="2"/>
             <a:r>
-              <a:rPr lang="en-US" smtClean="0"/>
+              <a:rPr lang="en-US"/>
               <a:t>Third level</a:t>
             </a:r>
           </a:p>
           <a:p>
             <a:pPr lvl="3"/>
             <a:r>
-              <a:rPr lang="en-US" smtClean="0"/>
+              <a:rPr lang="en-US"/>
               <a:t>Fourth level</a:t>
             </a:r>
           </a:p>
           <a:p>
             <a:pPr lvl="4"/>
             <a:r>
-              <a:rPr lang="en-US" smtClean="0"/>
+              <a:rPr lang="en-US"/>
               <a:t>Fifth level</a:t>
             </a:r>
-            <a:endParaRPr lang="en-US"/>
           </a:p>
         </p:txBody>
       </p:sp>
@@ -823,7 +832,7 @@
           <a:p>
             <a:fld id="{5BCAD085-E8A6-8845-BD4E-CB4CCA059FC4}" type="datetimeFigureOut">
               <a:rPr lang="en-US" smtClean="0"/>
-              <a:t>1/27/13</a:t>
+              <a:t>8/6/2026</a:t>
             </a:fld>
             <a:endParaRPr lang="en-US"/>
           </a:p>
@@ -926,10 +935,9 @@
           </a:lstStyle>
           <a:p>
             <a:r>
-              <a:rPr lang="en-US" smtClean="0"/>
+              <a:rPr lang="en-US"/>
               <a:t>Click to edit Master title style</a:t>
             </a:r>
-            <a:endParaRPr lang="en-US"/>
           </a:p>
         </p:txBody>
       </p:sp>
@@ -1046,7 +1054,7 @@
           <a:p>
             <a:pPr lvl="0"/>
             <a:r>
-              <a:rPr lang="en-US" smtClean="0"/>
+              <a:rPr lang="en-US"/>
               <a:t>Click to edit Master text styles</a:t>
             </a:r>
           </a:p>
@@ -1069,7 +1077,7 @@
           <a:p>
             <a:fld id="{5BCAD085-E8A6-8845-BD4E-CB4CCA059FC4}" type="datetimeFigureOut">
               <a:rPr lang="en-US" smtClean="0"/>
-              <a:t>1/27/13</a:t>
+              <a:t>8/6/2026</a:t>
             </a:fld>
             <a:endParaRPr lang="en-US"/>
           </a:p>
@@ -1163,10 +1171,9 @@
           <a:lstStyle/>
           <a:p>
             <a:r>
-              <a:rPr lang="en-US" smtClean="0"/>
+              <a:rPr lang="en-US"/>
               <a:t>Click to edit Master title style</a:t>
             </a:r>
-            <a:endParaRPr lang="en-US"/>
           </a:p>
         </p:txBody>
       </p:sp>
@@ -1220,38 +1227,37 @@
           <a:p>
             <a:pPr lvl="0"/>
             <a:r>
-              <a:rPr lang="en-US" smtClean="0"/>
+              <a:rPr lang="en-US"/>
               <a:t>Click to edit Master text styles</a:t>
             </a:r>
           </a:p>
           <a:p>
             <a:pPr lvl="1"/>
             <a:r>
-              <a:rPr lang="en-US" smtClean="0"/>
+              <a:rPr lang="en-US"/>
               <a:t>Second level</a:t>
             </a:r>
           </a:p>
           <a:p>
             <a:pPr lvl="2"/>
             <a:r>
-              <a:rPr lang="en-US" smtClean="0"/>
+              <a:rPr lang="en-US"/>
               <a:t>Third level</a:t>
             </a:r>
           </a:p>
           <a:p>
             <a:pPr lvl="3"/>
             <a:r>
-              <a:rPr lang="en-US" smtClean="0"/>
+              <a:rPr lang="en-US"/>
               <a:t>Fourth level</a:t>
             </a:r>
           </a:p>
           <a:p>
             <a:pPr lvl="4"/>
             <a:r>
-              <a:rPr lang="en-US" smtClean="0"/>
+              <a:rPr lang="en-US"/>
               <a:t>Fifth level</a:t>
             </a:r>
-            <a:endParaRPr lang="en-US"/>
           </a:p>
         </p:txBody>
       </p:sp>
@@ -1305,38 +1311,37 @@
           <a:p>
             <a:pPr lvl="0"/>
             <a:r>
-              <a:rPr lang="en-US" smtClean="0"/>
+              <a:rPr lang="en-US"/>
               <a:t>Click to edit Master text styles</a:t>
             </a:r>
           </a:p>
           <a:p>
             <a:pPr lvl="1"/>
             <a:r>
-              <a:rPr lang="en-US" smtClean="0"/>
+              <a:rPr lang="en-US"/>
               <a:t>Second level</a:t>
             </a:r>
           </a:p>
           <a:p>
             <a:pPr lvl="2"/>
             <a:r>
-              <a:rPr lang="en-US" smtClean="0"/>
+              <a:rPr lang="en-US"/>
               <a:t>Third level</a:t>
             </a:r>
           </a:p>
           <a:p>
             <a:pPr lvl="3"/>
             <a:r>
-              <a:rPr lang="en-US" smtClean="0"/>
+              <a:rPr lang="en-US"/>
               <a:t>Fourth level</a:t>
             </a:r>
           </a:p>
           <a:p>
             <a:pPr lvl="4"/>
             <a:r>
-              <a:rPr lang="en-US" smtClean="0"/>
+              <a:rPr lang="en-US"/>
               <a:t>Fifth level</a:t>
             </a:r>
-            <a:endParaRPr lang="en-US"/>
           </a:p>
         </p:txBody>
       </p:sp>
@@ -1357,7 +1362,7 @@
           <a:p>
             <a:fld id="{5BCAD085-E8A6-8845-BD4E-CB4CCA059FC4}" type="datetimeFigureOut">
               <a:rPr lang="en-US" smtClean="0"/>
-              <a:t>1/27/13</a:t>
+              <a:t>8/6/2026</a:t>
             </a:fld>
             <a:endParaRPr lang="en-US"/>
           </a:p>
@@ -1455,10 +1460,9 @@
           </a:lstStyle>
           <a:p>
             <a:r>
-              <a:rPr lang="en-US" smtClean="0"/>
+              <a:rPr lang="en-US"/>
               <a:t>Click to edit Master title style</a:t>
             </a:r>
-            <a:endParaRPr lang="en-US"/>
           </a:p>
         </p:txBody>
       </p:sp>
@@ -1521,7 +1525,7 @@
           <a:p>
             <a:pPr lvl="0"/>
             <a:r>
-              <a:rPr lang="en-US" smtClean="0"/>
+              <a:rPr lang="en-US"/>
               <a:t>Click to edit Master text styles</a:t>
             </a:r>
           </a:p>
@@ -1577,38 +1581,37 @@
           <a:p>
             <a:pPr lvl="0"/>
             <a:r>
-              <a:rPr lang="en-US" smtClean="0"/>
+              <a:rPr lang="en-US"/>
               <a:t>Click to edit Master text styles</a:t>
             </a:r>
           </a:p>
           <a:p>
             <a:pPr lvl="1"/>
             <a:r>
-              <a:rPr lang="en-US" smtClean="0"/>
+              <a:rPr lang="en-US"/>
               <a:t>Second level</a:t>
             </a:r>
           </a:p>
           <a:p>
             <a:pPr lvl="2"/>
             <a:r>
-              <a:rPr lang="en-US" smtClean="0"/>
+              <a:rPr lang="en-US"/>
               <a:t>Third level</a:t>
             </a:r>
           </a:p>
           <a:p>
             <a:pPr lvl="3"/>
             <a:r>
-              <a:rPr lang="en-US" smtClean="0"/>
+              <a:rPr lang="en-US"/>
               <a:t>Fourth level</a:t>
             </a:r>
           </a:p>
           <a:p>
             <a:pPr lvl="4"/>
             <a:r>
-              <a:rPr lang="en-US" smtClean="0"/>
+              <a:rPr lang="en-US"/>
               <a:t>Fifth level</a:t>
             </a:r>
-            <a:endParaRPr lang="en-US"/>
           </a:p>
         </p:txBody>
       </p:sp>
@@ -1671,7 +1674,7 @@
           <a:p>
             <a:pPr lvl="0"/>
             <a:r>
-              <a:rPr lang="en-US" smtClean="0"/>
+              <a:rPr lang="en-US"/>
               <a:t>Click to edit Master text styles</a:t>
             </a:r>
           </a:p>
@@ -1727,38 +1730,37 @@
           <a:p>
             <a:pPr lvl="0"/>
             <a:r>
-              <a:rPr lang="en-US" smtClean="0"/>
+              <a:rPr lang="en-US"/>
               <a:t>Click to edit Master text styles</a:t>
             </a:r>
           </a:p>
           <a:p>
             <a:pPr lvl="1"/>
             <a:r>
-              <a:rPr lang="en-US" smtClean="0"/>
+              <a:rPr lang="en-US"/>
               <a:t>Second level</a:t>
             </a:r>
           </a:p>
           <a:p>
             <a:pPr lvl="2"/>
             <a:r>
-              <a:rPr lang="en-US" smtClean="0"/>
+              <a:rPr lang="en-US"/>
               <a:t>Third level</a:t>
             </a:r>
           </a:p>
           <a:p>
             <a:pPr lvl="3"/>
             <a:r>
-              <a:rPr lang="en-US" smtClean="0"/>
+              <a:rPr lang="en-US"/>
               <a:t>Fourth level</a:t>
             </a:r>
           </a:p>
           <a:p>
             <a:pPr lvl="4"/>
             <a:r>
-              <a:rPr lang="en-US" smtClean="0"/>
+              <a:rPr lang="en-US"/>
               <a:t>Fifth level</a:t>
             </a:r>
-            <a:endParaRPr lang="en-US"/>
           </a:p>
         </p:txBody>
       </p:sp>
@@ -1779,7 +1781,7 @@
           <a:p>
             <a:fld id="{5BCAD085-E8A6-8845-BD4E-CB4CCA059FC4}" type="datetimeFigureOut">
               <a:rPr lang="en-US" smtClean="0"/>
-              <a:t>1/27/13</a:t>
+              <a:t>8/6/2026</a:t>
             </a:fld>
             <a:endParaRPr lang="en-US"/>
           </a:p>
@@ -1873,10 +1875,9 @@
           <a:lstStyle/>
           <a:p>
             <a:r>
-              <a:rPr lang="en-US" smtClean="0"/>
+              <a:rPr lang="en-US"/>
               <a:t>Click to edit Master title style</a:t>
             </a:r>
-            <a:endParaRPr lang="en-US"/>
           </a:p>
         </p:txBody>
       </p:sp>
@@ -1897,7 +1898,7 @@
           <a:p>
             <a:fld id="{5BCAD085-E8A6-8845-BD4E-CB4CCA059FC4}" type="datetimeFigureOut">
               <a:rPr lang="en-US" smtClean="0"/>
-              <a:t>1/27/13</a:t>
+              <a:t>8/6/2026</a:t>
             </a:fld>
             <a:endParaRPr lang="en-US"/>
           </a:p>
@@ -1992,7 +1993,7 @@
           <a:p>
             <a:fld id="{5BCAD085-E8A6-8845-BD4E-CB4CCA059FC4}" type="datetimeFigureOut">
               <a:rPr lang="en-US" smtClean="0"/>
-              <a:t>1/27/13</a:t>
+              <a:t>8/6/2026</a:t>
             </a:fld>
             <a:endParaRPr lang="en-US"/>
           </a:p>
@@ -2095,10 +2096,9 @@
           </a:lstStyle>
           <a:p>
             <a:r>
-              <a:rPr lang="en-US" smtClean="0"/>
+              <a:rPr lang="en-US"/>
               <a:t>Click to edit Master title style</a:t>
             </a:r>
-            <a:endParaRPr lang="en-US"/>
           </a:p>
         </p:txBody>
       </p:sp>
@@ -2152,38 +2152,37 @@
           <a:p>
             <a:pPr lvl="0"/>
             <a:r>
-              <a:rPr lang="en-US" smtClean="0"/>
+              <a:rPr lang="en-US"/>
               <a:t>Click to edit Master text styles</a:t>
             </a:r>
           </a:p>
           <a:p>
             <a:pPr lvl="1"/>
             <a:r>
-              <a:rPr lang="en-US" smtClean="0"/>
+              <a:rPr lang="en-US"/>
               <a:t>Second level</a:t>
             </a:r>
           </a:p>
           <a:p>
             <a:pPr lvl="2"/>
             <a:r>
-              <a:rPr lang="en-US" smtClean="0"/>
+              <a:rPr lang="en-US"/>
               <a:t>Third level</a:t>
             </a:r>
           </a:p>
           <a:p>
             <a:pPr lvl="3"/>
             <a:r>
-              <a:rPr lang="en-US" smtClean="0"/>
+              <a:rPr lang="en-US"/>
               <a:t>Fourth level</a:t>
             </a:r>
           </a:p>
           <a:p>
             <a:pPr lvl="4"/>
             <a:r>
-              <a:rPr lang="en-US" smtClean="0"/>
+              <a:rPr lang="en-US"/>
               <a:t>Fifth level</a:t>
             </a:r>
-            <a:endParaRPr lang="en-US"/>
           </a:p>
         </p:txBody>
       </p:sp>
@@ -2246,7 +2245,7 @@
           <a:p>
             <a:pPr lvl="0"/>
             <a:r>
-              <a:rPr lang="en-US" smtClean="0"/>
+              <a:rPr lang="en-US"/>
               <a:t>Click to edit Master text styles</a:t>
             </a:r>
           </a:p>
@@ -2269,7 +2268,7 @@
           <a:p>
             <a:fld id="{5BCAD085-E8A6-8845-BD4E-CB4CCA059FC4}" type="datetimeFigureOut">
               <a:rPr lang="en-US" smtClean="0"/>
-              <a:t>1/27/13</a:t>
+              <a:t>8/6/2026</a:t>
             </a:fld>
             <a:endParaRPr lang="en-US"/>
           </a:p>
@@ -2372,10 +2371,9 @@
           </a:lstStyle>
           <a:p>
             <a:r>
-              <a:rPr lang="en-US" smtClean="0"/>
+              <a:rPr lang="en-US"/>
               <a:t>Click to edit Master title style</a:t>
             </a:r>
-            <a:endParaRPr lang="en-US"/>
           </a:p>
         </p:txBody>
       </p:sp>
@@ -2499,7 +2497,7 @@
           <a:p>
             <a:pPr lvl="0"/>
             <a:r>
-              <a:rPr lang="en-US" smtClean="0"/>
+              <a:rPr lang="en-US"/>
               <a:t>Click to edit Master text styles</a:t>
             </a:r>
           </a:p>
@@ -2522,7 +2520,7 @@
           <a:p>
             <a:fld id="{5BCAD085-E8A6-8845-BD4E-CB4CCA059FC4}" type="datetimeFigureOut">
               <a:rPr lang="en-US" smtClean="0"/>
-              <a:t>1/27/13</a:t>
+              <a:t>8/6/2026</a:t>
             </a:fld>
             <a:endParaRPr lang="en-US"/>
           </a:p>
@@ -2631,10 +2629,9 @@
           <a:lstStyle/>
           <a:p>
             <a:r>
-              <a:rPr lang="en-US" smtClean="0"/>
+              <a:rPr lang="en-US"/>
               <a:t>Click to edit Master title style</a:t>
             </a:r>
-            <a:endParaRPr lang="en-US"/>
           </a:p>
         </p:txBody>
       </p:sp>
@@ -2665,38 +2662,37 @@
           <a:p>
             <a:pPr lvl="0"/>
             <a:r>
-              <a:rPr lang="en-US" smtClean="0"/>
+              <a:rPr lang="en-US"/>
               <a:t>Click to edit Master text styles</a:t>
             </a:r>
           </a:p>
           <a:p>
             <a:pPr lvl="1"/>
             <a:r>
-              <a:rPr lang="en-US" smtClean="0"/>
+              <a:rPr lang="en-US"/>
               <a:t>Second level</a:t>
             </a:r>
           </a:p>
           <a:p>
             <a:pPr lvl="2"/>
             <a:r>
-              <a:rPr lang="en-US" smtClean="0"/>
+              <a:rPr lang="en-US"/>
               <a:t>Third level</a:t>
             </a:r>
           </a:p>
           <a:p>
             <a:pPr lvl="3"/>
             <a:r>
-              <a:rPr lang="en-US" smtClean="0"/>
+              <a:rPr lang="en-US"/>
               <a:t>Fourth level</a:t>
             </a:r>
           </a:p>
           <a:p>
             <a:pPr lvl="4"/>
             <a:r>
-              <a:rPr lang="en-US" smtClean="0"/>
+              <a:rPr lang="en-US"/>
               <a:t>Fifth level</a:t>
             </a:r>
-            <a:endParaRPr lang="en-US"/>
           </a:p>
         </p:txBody>
       </p:sp>
@@ -2735,7 +2731,7 @@
           <a:p>
             <a:fld id="{5BCAD085-E8A6-8845-BD4E-CB4CCA059FC4}" type="datetimeFigureOut">
               <a:rPr lang="en-US" smtClean="0"/>
-              <a:t>1/27/13</a:t>
+              <a:t>8/6/2026</a:t>
             </a:fld>
             <a:endParaRPr lang="en-US"/>
           </a:p>
@@ -3094,7 +3090,7 @@
 </file>
 
 <file path=ppt/slides/slide1.xml><?xml version="1.0" encoding="utf-8"?>
-<p:sld xmlns:a="http://schemas.openxmlformats.org/drawingml/2006/main" xmlns:p="http://schemas.openxmlformats.org/presentationml/2006/main" xmlns:r="http://schemas.openxmlformats.org/officeDocument/2006/relationships">
+<p:sld xmlns:a="http://schemas.openxmlformats.org/drawingml/2006/main" xmlns:r="http://schemas.openxmlformats.org/officeDocument/2006/relationships" xmlns:p="http://schemas.openxmlformats.org/presentationml/2006/main">
   <p:cSld>
     <p:bg>
       <p:bgPr>
@@ -3110,7 +3106,14 @@
         <p:cNvGrpSpPr/>
         <p:nvPr/>
       </p:nvGrpSpPr>
-      <p:grpSpPr/>
+      <p:grpSpPr>
+        <a:xfrm>
+          <a:off x="0" y="0"/>
+          <a:ext cx="0" cy="0"/>
+          <a:chOff x="0" y="0"/>
+          <a:chExt cx="0" cy="0"/>
+        </a:xfrm>
+      </p:grpSpPr>
       <p:sp>
         <p:nvSpPr>
           <p:cNvPr id="2" name="Rectangle 1"/>
@@ -3151,6 +3154,7 @@
           <a:lstStyle/>
           <a:p>
             <a:pPr algn="ctr"/>
+            <a:endParaRPr/>
           </a:p>
         </p:txBody>
       </p:sp>
@@ -3178,7 +3182,7 @@
           <a:p>
             <a:pPr algn="l"/>
             <a:r>
-              <a:rPr sz="8000" b="1">
+              <a:rPr sz="8000" b="1" dirty="0">
                 <a:solidFill>
                   <a:srgbClr val="FFFFFF"/>
                 </a:solidFill>
@@ -3296,6 +3300,7 @@
           <a:lstStyle/>
           <a:p>
             <a:pPr algn="ctr"/>
+            <a:endParaRPr/>
           </a:p>
         </p:txBody>
       </p:sp>
@@ -3376,6 +3381,7 @@
           <a:lstStyle/>
           <a:p>
             <a:pPr algn="ctr"/>
+            <a:endParaRPr/>
           </a:p>
         </p:txBody>
       </p:sp>
@@ -3489,6 +3495,7 @@
           <a:lstStyle/>
           <a:p>
             <a:pPr algn="ctr"/>
+            <a:endParaRPr/>
           </a:p>
         </p:txBody>
       </p:sp>
@@ -3603,6 +3610,7 @@
           <a:lstStyle/>
           <a:p>
             <a:pPr algn="ctr"/>
+            <a:endParaRPr/>
           </a:p>
         </p:txBody>
       </p:sp>
@@ -3716,6 +3724,7 @@
           <a:lstStyle/>
           <a:p>
             <a:pPr algn="ctr"/>
+            <a:endParaRPr/>
           </a:p>
         </p:txBody>
       </p:sp>
@@ -3827,6 +3836,7 @@
           <a:lstStyle/>
           <a:p>
             <a:pPr algn="ctr"/>
+            <a:endParaRPr/>
           </a:p>
         </p:txBody>
       </p:sp>
@@ -3873,7 +3883,7 @@
 </file>
 
 <file path=ppt/slides/slide10.xml><?xml version="1.0" encoding="utf-8"?>
-<p:sld xmlns:a="http://schemas.openxmlformats.org/drawingml/2006/main" xmlns:p="http://schemas.openxmlformats.org/presentationml/2006/main" xmlns:r="http://schemas.openxmlformats.org/officeDocument/2006/relationships">
+<p:sld xmlns:a="http://schemas.openxmlformats.org/drawingml/2006/main" xmlns:r="http://schemas.openxmlformats.org/officeDocument/2006/relationships" xmlns:p="http://schemas.openxmlformats.org/presentationml/2006/main">
   <p:cSld>
     <p:bg>
       <p:bgPr>
@@ -3889,7 +3899,14 @@
         <p:cNvGrpSpPr/>
         <p:nvPr/>
       </p:nvGrpSpPr>
-      <p:grpSpPr/>
+      <p:grpSpPr>
+        <a:xfrm>
+          <a:off x="0" y="0"/>
+          <a:ext cx="0" cy="0"/>
+          <a:chOff x="0" y="0"/>
+          <a:chExt cx="0" cy="0"/>
+        </a:xfrm>
+      </p:grpSpPr>
       <p:sp>
         <p:nvSpPr>
           <p:cNvPr id="2" name="Rectangle 1"/>
@@ -3930,6 +3947,7 @@
           <a:lstStyle/>
           <a:p>
             <a:pPr algn="ctr"/>
+            <a:endParaRPr/>
           </a:p>
         </p:txBody>
       </p:sp>
@@ -4007,6 +4025,7 @@
           <a:lstStyle/>
           <a:p>
             <a:pPr algn="ctr"/>
+            <a:endParaRPr/>
           </a:p>
         </p:txBody>
       </p:sp>
@@ -4084,6 +4103,7 @@
           <a:lstStyle/>
           <a:p>
             <a:pPr algn="ctr"/>
+            <a:endParaRPr/>
           </a:p>
         </p:txBody>
       </p:sp>
@@ -4331,6 +4351,7 @@
           <a:lstStyle/>
           <a:p>
             <a:pPr algn="ctr"/>
+            <a:endParaRPr/>
           </a:p>
         </p:txBody>
       </p:sp>
@@ -4578,6 +4599,7 @@
           <a:lstStyle/>
           <a:p>
             <a:pPr algn="ctr"/>
+            <a:endParaRPr/>
           </a:p>
         </p:txBody>
       </p:sp>
@@ -4825,6 +4847,7 @@
           <a:lstStyle/>
           <a:p>
             <a:pPr algn="ctr"/>
+            <a:endParaRPr/>
           </a:p>
         </p:txBody>
       </p:sp>
@@ -5072,6 +5095,7 @@
           <a:lstStyle/>
           <a:p>
             <a:pPr algn="ctr"/>
+            <a:endParaRPr/>
           </a:p>
         </p:txBody>
       </p:sp>
@@ -5319,6 +5343,7 @@
           <a:lstStyle/>
           <a:p>
             <a:pPr algn="ctr"/>
+            <a:endParaRPr/>
           </a:p>
         </p:txBody>
       </p:sp>
@@ -5603,7 +5628,7 @@
 </file>
 
 <file path=ppt/slides/slide11.xml><?xml version="1.0" encoding="utf-8"?>
-<p:sld xmlns:a="http://schemas.openxmlformats.org/drawingml/2006/main" xmlns:p="http://schemas.openxmlformats.org/presentationml/2006/main" xmlns:r="http://schemas.openxmlformats.org/officeDocument/2006/relationships">
+<p:sld xmlns:a="http://schemas.openxmlformats.org/drawingml/2006/main" xmlns:r="http://schemas.openxmlformats.org/officeDocument/2006/relationships" xmlns:p="http://schemas.openxmlformats.org/presentationml/2006/main">
   <p:cSld>
     <p:bg>
       <p:bgPr>
@@ -5619,7 +5644,14 @@
         <p:cNvGrpSpPr/>
         <p:nvPr/>
       </p:nvGrpSpPr>
-      <p:grpSpPr/>
+      <p:grpSpPr>
+        <a:xfrm>
+          <a:off x="0" y="0"/>
+          <a:ext cx="0" cy="0"/>
+          <a:chOff x="0" y="0"/>
+          <a:chExt cx="0" cy="0"/>
+        </a:xfrm>
+      </p:grpSpPr>
       <p:sp>
         <p:nvSpPr>
           <p:cNvPr id="2" name="Rectangle 1"/>
@@ -5660,6 +5692,7 @@
           <a:lstStyle/>
           <a:p>
             <a:pPr algn="ctr"/>
+            <a:endParaRPr/>
           </a:p>
         </p:txBody>
       </p:sp>
@@ -5737,6 +5770,7 @@
           <a:lstStyle/>
           <a:p>
             <a:pPr algn="ctr"/>
+            <a:endParaRPr/>
           </a:p>
         </p:txBody>
       </p:sp>
@@ -5816,6 +5850,7 @@
           <a:lstStyle/>
           <a:p>
             <a:pPr algn="ctr"/>
+            <a:endParaRPr/>
           </a:p>
         </p:txBody>
       </p:sp>
@@ -5964,6 +5999,7 @@
           <a:lstStyle/>
           <a:p>
             <a:pPr algn="ctr"/>
+            <a:endParaRPr/>
           </a:p>
         </p:txBody>
       </p:sp>
@@ -6112,6 +6148,7 @@
           <a:lstStyle/>
           <a:p>
             <a:pPr algn="ctr"/>
+            <a:endParaRPr/>
           </a:p>
         </p:txBody>
       </p:sp>
@@ -6362,7 +6399,7 @@
 </file>
 
 <file path=ppt/slides/slide12.xml><?xml version="1.0" encoding="utf-8"?>
-<p:sld xmlns:a="http://schemas.openxmlformats.org/drawingml/2006/main" xmlns:p="http://schemas.openxmlformats.org/presentationml/2006/main" xmlns:r="http://schemas.openxmlformats.org/officeDocument/2006/relationships">
+<p:sld xmlns:a="http://schemas.openxmlformats.org/drawingml/2006/main" xmlns:r="http://schemas.openxmlformats.org/officeDocument/2006/relationships" xmlns:p="http://schemas.openxmlformats.org/presentationml/2006/main">
   <p:cSld>
     <p:bg>
       <p:bgPr>
@@ -6378,7 +6415,14 @@
         <p:cNvGrpSpPr/>
         <p:nvPr/>
       </p:nvGrpSpPr>
-      <p:grpSpPr/>
+      <p:grpSpPr>
+        <a:xfrm>
+          <a:off x="0" y="0"/>
+          <a:ext cx="0" cy="0"/>
+          <a:chOff x="0" y="0"/>
+          <a:chExt cx="0" cy="0"/>
+        </a:xfrm>
+      </p:grpSpPr>
       <p:sp>
         <p:nvSpPr>
           <p:cNvPr id="2" name="Rectangle 1"/>
@@ -6419,6 +6463,7 @@
           <a:lstStyle/>
           <a:p>
             <a:pPr algn="ctr"/>
+            <a:endParaRPr/>
           </a:p>
         </p:txBody>
       </p:sp>
@@ -6496,6 +6541,7 @@
           <a:lstStyle/>
           <a:p>
             <a:pPr algn="ctr"/>
+            <a:endParaRPr/>
           </a:p>
         </p:txBody>
       </p:sp>
@@ -6539,6 +6585,7 @@
           <a:lstStyle/>
           <a:p>
             <a:pPr algn="ctr"/>
+            <a:endParaRPr/>
           </a:p>
         </p:txBody>
       </p:sp>
@@ -6718,6 +6765,7 @@
           <a:lstStyle/>
           <a:p>
             <a:pPr algn="ctr"/>
+            <a:endParaRPr/>
           </a:p>
         </p:txBody>
       </p:sp>
@@ -6897,6 +6945,7 @@
           <a:lstStyle/>
           <a:p>
             <a:pPr algn="ctr"/>
+            <a:endParaRPr/>
           </a:p>
         </p:txBody>
       </p:sp>
@@ -7076,6 +7125,7 @@
           <a:lstStyle/>
           <a:p>
             <a:pPr algn="ctr"/>
+            <a:endParaRPr/>
           </a:p>
         </p:txBody>
       </p:sp>
@@ -7255,6 +7305,7 @@
           <a:lstStyle/>
           <a:p>
             <a:pPr algn="ctr"/>
+            <a:endParaRPr/>
           </a:p>
         </p:txBody>
       </p:sp>
@@ -7434,6 +7485,7 @@
           <a:lstStyle/>
           <a:p>
             <a:pPr algn="ctr"/>
+            <a:endParaRPr/>
           </a:p>
         </p:txBody>
       </p:sp>
@@ -7613,6 +7665,7 @@
           <a:lstStyle/>
           <a:p>
             <a:pPr algn="ctr"/>
+            <a:endParaRPr/>
           </a:p>
         </p:txBody>
       </p:sp>
@@ -7792,6 +7845,7 @@
           <a:lstStyle/>
           <a:p>
             <a:pPr algn="ctr"/>
+            <a:endParaRPr/>
           </a:p>
         </p:txBody>
       </p:sp>
@@ -7971,6 +8025,7 @@
           <a:lstStyle/>
           <a:p>
             <a:pPr algn="ctr"/>
+            <a:endParaRPr/>
           </a:p>
         </p:txBody>
       </p:sp>
@@ -8150,6 +8205,7 @@
           <a:lstStyle/>
           <a:p>
             <a:pPr algn="ctr"/>
+            <a:endParaRPr/>
           </a:p>
         </p:txBody>
       </p:sp>
@@ -8329,6 +8385,7 @@
           <a:lstStyle/>
           <a:p>
             <a:pPr algn="ctr"/>
+            <a:endParaRPr/>
           </a:p>
         </p:txBody>
       </p:sp>
@@ -8511,7 +8568,7 @@
 </file>
 
 <file path=ppt/slides/slide13.xml><?xml version="1.0" encoding="utf-8"?>
-<p:sld xmlns:a="http://schemas.openxmlformats.org/drawingml/2006/main" xmlns:p="http://schemas.openxmlformats.org/presentationml/2006/main" xmlns:r="http://schemas.openxmlformats.org/officeDocument/2006/relationships">
+<p:sld xmlns:a="http://schemas.openxmlformats.org/drawingml/2006/main" xmlns:r="http://schemas.openxmlformats.org/officeDocument/2006/relationships" xmlns:p="http://schemas.openxmlformats.org/presentationml/2006/main">
   <p:cSld>
     <p:bg>
       <p:bgPr>
@@ -8527,7 +8584,14 @@
         <p:cNvGrpSpPr/>
         <p:nvPr/>
       </p:nvGrpSpPr>
-      <p:grpSpPr/>
+      <p:grpSpPr>
+        <a:xfrm>
+          <a:off x="0" y="0"/>
+          <a:ext cx="0" cy="0"/>
+          <a:chOff x="0" y="0"/>
+          <a:chExt cx="0" cy="0"/>
+        </a:xfrm>
+      </p:grpSpPr>
       <p:sp>
         <p:nvSpPr>
           <p:cNvPr id="2" name="Rectangle 1"/>
@@ -8568,6 +8632,7 @@
           <a:lstStyle/>
           <a:p>
             <a:pPr algn="ctr"/>
+            <a:endParaRPr/>
           </a:p>
         </p:txBody>
       </p:sp>
@@ -8645,6 +8710,7 @@
           <a:lstStyle/>
           <a:p>
             <a:pPr algn="ctr"/>
+            <a:endParaRPr/>
           </a:p>
         </p:txBody>
       </p:sp>
@@ -8962,6 +9028,7 @@
           <a:lstStyle/>
           <a:p>
             <a:pPr algn="ctr"/>
+            <a:endParaRPr/>
           </a:p>
         </p:txBody>
       </p:sp>
@@ -9005,6 +9072,7 @@
           <a:lstStyle/>
           <a:p>
             <a:pPr algn="ctr"/>
+            <a:endParaRPr/>
           </a:p>
         </p:txBody>
       </p:sp>
@@ -9167,14 +9235,7 @@
           <a:lstStyle/>
           <a:p>
             <a:pPr algn="l"/>
-            <a:r>
-              <a:rPr sz="1000" b="0">
-                <a:solidFill>
-                  <a:srgbClr val="FFFFFF"/>
-                </a:solidFill>
-              </a:rPr>
-              <a:t/>
-            </a:r>
+            <a:endParaRPr/>
           </a:p>
         </p:txBody>
       </p:sp>
@@ -9391,7 +9452,7 @@
 </file>
 
 <file path=ppt/slides/slide14.xml><?xml version="1.0" encoding="utf-8"?>
-<p:sld xmlns:a="http://schemas.openxmlformats.org/drawingml/2006/main" xmlns:p="http://schemas.openxmlformats.org/presentationml/2006/main" xmlns:r="http://schemas.openxmlformats.org/officeDocument/2006/relationships">
+<p:sld xmlns:a="http://schemas.openxmlformats.org/drawingml/2006/main" xmlns:r="http://schemas.openxmlformats.org/officeDocument/2006/relationships" xmlns:p="http://schemas.openxmlformats.org/presentationml/2006/main">
   <p:cSld>
     <p:bg>
       <p:bgPr>
@@ -9407,7 +9468,14 @@
         <p:cNvGrpSpPr/>
         <p:nvPr/>
       </p:nvGrpSpPr>
-      <p:grpSpPr/>
+      <p:grpSpPr>
+        <a:xfrm>
+          <a:off x="0" y="0"/>
+          <a:ext cx="0" cy="0"/>
+          <a:chOff x="0" y="0"/>
+          <a:chExt cx="0" cy="0"/>
+        </a:xfrm>
+      </p:grpSpPr>
       <p:sp>
         <p:nvSpPr>
           <p:cNvPr id="2" name="Rectangle 1"/>
@@ -9448,6 +9516,7 @@
           <a:lstStyle/>
           <a:p>
             <a:pPr algn="ctr"/>
+            <a:endParaRPr/>
           </a:p>
         </p:txBody>
       </p:sp>
@@ -9525,6 +9594,7 @@
           <a:lstStyle/>
           <a:p>
             <a:pPr algn="ctr"/>
+            <a:endParaRPr/>
           </a:p>
         </p:txBody>
       </p:sp>
@@ -9570,6 +9640,7 @@
           <a:lstStyle/>
           <a:p>
             <a:pPr algn="ctr"/>
+            <a:endParaRPr/>
           </a:p>
         </p:txBody>
       </p:sp>
@@ -9921,6 +9992,7 @@
           <a:lstStyle/>
           <a:p>
             <a:pPr algn="ctr"/>
+            <a:endParaRPr/>
           </a:p>
         </p:txBody>
       </p:sp>
@@ -10173,6 +10245,7 @@
           <a:lstStyle/>
           <a:p>
             <a:pPr algn="ctr"/>
+            <a:endParaRPr/>
           </a:p>
         </p:txBody>
       </p:sp>
@@ -10219,7 +10292,7 @@
 </file>
 
 <file path=ppt/slides/slide15.xml><?xml version="1.0" encoding="utf-8"?>
-<p:sld xmlns:a="http://schemas.openxmlformats.org/drawingml/2006/main" xmlns:p="http://schemas.openxmlformats.org/presentationml/2006/main" xmlns:r="http://schemas.openxmlformats.org/officeDocument/2006/relationships">
+<p:sld xmlns:a="http://schemas.openxmlformats.org/drawingml/2006/main" xmlns:r="http://schemas.openxmlformats.org/officeDocument/2006/relationships" xmlns:p="http://schemas.openxmlformats.org/presentationml/2006/main">
   <p:cSld>
     <p:bg>
       <p:bgPr>
@@ -10235,7 +10308,14 @@
         <p:cNvGrpSpPr/>
         <p:nvPr/>
       </p:nvGrpSpPr>
-      <p:grpSpPr/>
+      <p:grpSpPr>
+        <a:xfrm>
+          <a:off x="0" y="0"/>
+          <a:ext cx="0" cy="0"/>
+          <a:chOff x="0" y="0"/>
+          <a:chExt cx="0" cy="0"/>
+        </a:xfrm>
+      </p:grpSpPr>
       <p:sp>
         <p:nvSpPr>
           <p:cNvPr id="2" name="Rectangle 1"/>
@@ -10276,6 +10356,7 @@
           <a:lstStyle/>
           <a:p>
             <a:pPr algn="ctr"/>
+            <a:endParaRPr/>
           </a:p>
         </p:txBody>
       </p:sp>
@@ -10387,6 +10468,7 @@
           <a:lstStyle/>
           <a:p>
             <a:pPr algn="ctr"/>
+            <a:endParaRPr/>
           </a:p>
         </p:txBody>
       </p:sp>
@@ -10430,6 +10512,7 @@
           <a:lstStyle/>
           <a:p>
             <a:pPr algn="ctr"/>
+            <a:endParaRPr/>
           </a:p>
         </p:txBody>
       </p:sp>
@@ -10745,6 +10828,7 @@
           <a:lstStyle/>
           <a:p>
             <a:pPr algn="ctr"/>
+            <a:endParaRPr/>
           </a:p>
         </p:txBody>
       </p:sp>
@@ -10856,6 +10940,7 @@
           <a:lstStyle/>
           <a:p>
             <a:pPr algn="ctr"/>
+            <a:endParaRPr/>
           </a:p>
         </p:txBody>
       </p:sp>
@@ -10899,6 +10984,7 @@
           <a:lstStyle/>
           <a:p>
             <a:pPr algn="ctr"/>
+            <a:endParaRPr/>
           </a:p>
         </p:txBody>
       </p:sp>
@@ -11146,6 +11232,7 @@
           <a:lstStyle/>
           <a:p>
             <a:pPr algn="ctr"/>
+            <a:endParaRPr/>
           </a:p>
         </p:txBody>
       </p:sp>
@@ -11257,6 +11344,7 @@
           <a:lstStyle/>
           <a:p>
             <a:pPr algn="ctr"/>
+            <a:endParaRPr/>
           </a:p>
         </p:txBody>
       </p:sp>
@@ -11300,6 +11388,7 @@
           <a:lstStyle/>
           <a:p>
             <a:pPr algn="ctr"/>
+            <a:endParaRPr/>
           </a:p>
         </p:txBody>
       </p:sp>
@@ -11547,6 +11636,7 @@
           <a:lstStyle/>
           <a:p>
             <a:pPr algn="ctr"/>
+            <a:endParaRPr/>
           </a:p>
         </p:txBody>
       </p:sp>
@@ -11658,6 +11748,7 @@
           <a:lstStyle/>
           <a:p>
             <a:pPr algn="ctr"/>
+            <a:endParaRPr/>
           </a:p>
         </p:txBody>
       </p:sp>
@@ -11701,6 +11792,7 @@
           <a:lstStyle/>
           <a:p>
             <a:pPr algn="ctr"/>
+            <a:endParaRPr/>
           </a:p>
         </p:txBody>
       </p:sp>
@@ -11948,6 +12040,7 @@
           <a:lstStyle/>
           <a:p>
             <a:pPr algn="ctr"/>
+            <a:endParaRPr/>
           </a:p>
         </p:txBody>
       </p:sp>
@@ -12059,6 +12152,7 @@
           <a:lstStyle/>
           <a:p>
             <a:pPr algn="ctr"/>
+            <a:endParaRPr/>
           </a:p>
         </p:txBody>
       </p:sp>
@@ -12102,6 +12196,7 @@
           <a:lstStyle/>
           <a:p>
             <a:pPr algn="ctr"/>
+            <a:endParaRPr/>
           </a:p>
         </p:txBody>
       </p:sp>
@@ -12349,6 +12444,7 @@
           <a:lstStyle/>
           <a:p>
             <a:pPr algn="ctr"/>
+            <a:endParaRPr/>
           </a:p>
         </p:txBody>
       </p:sp>
@@ -12460,6 +12556,7 @@
           <a:lstStyle/>
           <a:p>
             <a:pPr algn="ctr"/>
+            <a:endParaRPr/>
           </a:p>
         </p:txBody>
       </p:sp>
@@ -12503,6 +12600,7 @@
           <a:lstStyle/>
           <a:p>
             <a:pPr algn="ctr"/>
+            <a:endParaRPr/>
           </a:p>
         </p:txBody>
       </p:sp>
@@ -12750,6 +12848,7 @@
           <a:lstStyle/>
           <a:p>
             <a:pPr algn="ctr"/>
+            <a:endParaRPr/>
           </a:p>
         </p:txBody>
       </p:sp>
@@ -12861,6 +12960,7 @@
           <a:lstStyle/>
           <a:p>
             <a:pPr algn="ctr"/>
+            <a:endParaRPr/>
           </a:p>
         </p:txBody>
       </p:sp>
@@ -12904,6 +13004,7 @@
           <a:lstStyle/>
           <a:p>
             <a:pPr algn="ctr"/>
+            <a:endParaRPr/>
           </a:p>
         </p:txBody>
       </p:sp>
@@ -13151,6 +13252,7 @@
           <a:lstStyle/>
           <a:p>
             <a:pPr algn="ctr"/>
+            <a:endParaRPr/>
           </a:p>
         </p:txBody>
       </p:sp>
@@ -13262,6 +13364,7 @@
           <a:lstStyle/>
           <a:p>
             <a:pPr algn="ctr"/>
+            <a:endParaRPr/>
           </a:p>
         </p:txBody>
       </p:sp>
@@ -13305,6 +13408,7 @@
           <a:lstStyle/>
           <a:p>
             <a:pPr algn="ctr"/>
+            <a:endParaRPr/>
           </a:p>
         </p:txBody>
       </p:sp>
@@ -13552,6 +13656,7 @@
           <a:lstStyle/>
           <a:p>
             <a:pPr algn="ctr"/>
+            <a:endParaRPr/>
           </a:p>
         </p:txBody>
       </p:sp>
@@ -13663,6 +13768,7 @@
           <a:lstStyle/>
           <a:p>
             <a:pPr algn="ctr"/>
+            <a:endParaRPr/>
           </a:p>
         </p:txBody>
       </p:sp>
@@ -13706,6 +13812,7 @@
           <a:lstStyle/>
           <a:p>
             <a:pPr algn="ctr"/>
+            <a:endParaRPr/>
           </a:p>
         </p:txBody>
       </p:sp>
@@ -13953,6 +14060,7 @@
           <a:lstStyle/>
           <a:p>
             <a:pPr algn="ctr"/>
+            <a:endParaRPr/>
           </a:p>
         </p:txBody>
       </p:sp>
@@ -14064,6 +14172,7 @@
           <a:lstStyle/>
           <a:p>
             <a:pPr algn="ctr"/>
+            <a:endParaRPr/>
           </a:p>
         </p:txBody>
       </p:sp>
@@ -14107,6 +14216,7 @@
           <a:lstStyle/>
           <a:p>
             <a:pPr algn="ctr"/>
+            <a:endParaRPr/>
           </a:p>
         </p:txBody>
       </p:sp>
@@ -14354,6 +14464,7 @@
           <a:lstStyle/>
           <a:p>
             <a:pPr algn="ctr"/>
+            <a:endParaRPr/>
           </a:p>
         </p:txBody>
       </p:sp>
@@ -14465,6 +14576,7 @@
           <a:lstStyle/>
           <a:p>
             <a:pPr algn="ctr"/>
+            <a:endParaRPr/>
           </a:p>
         </p:txBody>
       </p:sp>
@@ -14508,6 +14620,7 @@
           <a:lstStyle/>
           <a:p>
             <a:pPr algn="ctr"/>
+            <a:endParaRPr/>
           </a:p>
         </p:txBody>
       </p:sp>
@@ -14755,6 +14868,7 @@
           <a:lstStyle/>
           <a:p>
             <a:pPr algn="ctr"/>
+            <a:endParaRPr/>
           </a:p>
         </p:txBody>
       </p:sp>
@@ -14866,6 +14980,7 @@
           <a:lstStyle/>
           <a:p>
             <a:pPr algn="ctr"/>
+            <a:endParaRPr/>
           </a:p>
         </p:txBody>
       </p:sp>
@@ -14909,6 +15024,7 @@
           <a:lstStyle/>
           <a:p>
             <a:pPr algn="ctr"/>
+            <a:endParaRPr/>
           </a:p>
         </p:txBody>
       </p:sp>
@@ -15156,6 +15272,7 @@
           <a:lstStyle/>
           <a:p>
             <a:pPr algn="ctr"/>
+            <a:endParaRPr/>
           </a:p>
         </p:txBody>
       </p:sp>
@@ -15267,6 +15384,7 @@
           <a:lstStyle/>
           <a:p>
             <a:pPr algn="ctr"/>
+            <a:endParaRPr/>
           </a:p>
         </p:txBody>
       </p:sp>
@@ -15310,6 +15428,7 @@
           <a:lstStyle/>
           <a:p>
             <a:pPr algn="ctr"/>
+            <a:endParaRPr/>
           </a:p>
         </p:txBody>
       </p:sp>
@@ -15557,6 +15676,7 @@
           <a:lstStyle/>
           <a:p>
             <a:pPr algn="ctr"/>
+            <a:endParaRPr/>
           </a:p>
         </p:txBody>
       </p:sp>
@@ -15668,6 +15788,7 @@
           <a:lstStyle/>
           <a:p>
             <a:pPr algn="ctr"/>
+            <a:endParaRPr/>
           </a:p>
         </p:txBody>
       </p:sp>
@@ -15745,6 +15866,7 @@
           <a:lstStyle/>
           <a:p>
             <a:pPr algn="ctr"/>
+            <a:endParaRPr/>
           </a:p>
         </p:txBody>
       </p:sp>
@@ -15788,6 +15910,7 @@
           <a:lstStyle/>
           <a:p>
             <a:pPr algn="ctr"/>
+            <a:endParaRPr/>
           </a:p>
         </p:txBody>
       </p:sp>
@@ -15936,7 +16059,7 @@
 </file>
 
 <file path=ppt/slides/slide16.xml><?xml version="1.0" encoding="utf-8"?>
-<p:sld xmlns:a="http://schemas.openxmlformats.org/drawingml/2006/main" xmlns:p="http://schemas.openxmlformats.org/presentationml/2006/main" xmlns:r="http://schemas.openxmlformats.org/officeDocument/2006/relationships">
+<p:sld xmlns:a="http://schemas.openxmlformats.org/drawingml/2006/main" xmlns:r="http://schemas.openxmlformats.org/officeDocument/2006/relationships" xmlns:p="http://schemas.openxmlformats.org/presentationml/2006/main">
   <p:cSld>
     <p:bg>
       <p:bgPr>
@@ -15952,7 +16075,14 @@
         <p:cNvGrpSpPr/>
         <p:nvPr/>
       </p:nvGrpSpPr>
-      <p:grpSpPr/>
+      <p:grpSpPr>
+        <a:xfrm>
+          <a:off x="0" y="0"/>
+          <a:ext cx="0" cy="0"/>
+          <a:chOff x="0" y="0"/>
+          <a:chExt cx="0" cy="0"/>
+        </a:xfrm>
+      </p:grpSpPr>
       <p:sp>
         <p:nvSpPr>
           <p:cNvPr id="2" name="Rectangle 1"/>
@@ -15993,6 +16123,7 @@
           <a:lstStyle/>
           <a:p>
             <a:pPr algn="ctr"/>
+            <a:endParaRPr/>
           </a:p>
         </p:txBody>
       </p:sp>
@@ -16104,6 +16235,7 @@
           <a:lstStyle/>
           <a:p>
             <a:pPr algn="ctr"/>
+            <a:endParaRPr/>
           </a:p>
         </p:txBody>
       </p:sp>
@@ -16149,6 +16281,7 @@
           <a:lstStyle/>
           <a:p>
             <a:pPr algn="ctr"/>
+            <a:endParaRPr/>
           </a:p>
         </p:txBody>
       </p:sp>
@@ -16328,6 +16461,7 @@
           <a:lstStyle/>
           <a:p>
             <a:pPr algn="ctr"/>
+            <a:endParaRPr/>
           </a:p>
         </p:txBody>
       </p:sp>
@@ -16541,6 +16675,7 @@
           <a:lstStyle/>
           <a:p>
             <a:pPr algn="ctr"/>
+            <a:endParaRPr/>
           </a:p>
         </p:txBody>
       </p:sp>
@@ -16652,6 +16787,7 @@
           <a:lstStyle/>
           <a:p>
             <a:pPr algn="ctr"/>
+            <a:endParaRPr/>
           </a:p>
         </p:txBody>
       </p:sp>
@@ -16695,6 +16831,7 @@
           <a:lstStyle/>
           <a:p>
             <a:pPr algn="ctr"/>
+            <a:endParaRPr/>
           </a:p>
         </p:txBody>
       </p:sp>
@@ -16738,6 +16875,7 @@
           <a:lstStyle/>
           <a:p>
             <a:pPr algn="ctr"/>
+            <a:endParaRPr/>
           </a:p>
         </p:txBody>
       </p:sp>
@@ -16849,6 +16987,7 @@
           <a:lstStyle/>
           <a:p>
             <a:pPr algn="ctr"/>
+            <a:endParaRPr/>
           </a:p>
         </p:txBody>
       </p:sp>
@@ -16960,6 +17099,7 @@
           <a:lstStyle/>
           <a:p>
             <a:pPr algn="ctr"/>
+            <a:endParaRPr/>
           </a:p>
         </p:txBody>
       </p:sp>
@@ -17003,6 +17143,7 @@
           <a:lstStyle/>
           <a:p>
             <a:pPr algn="ctr"/>
+            <a:endParaRPr/>
           </a:p>
         </p:txBody>
       </p:sp>
@@ -17046,6 +17187,7 @@
           <a:lstStyle/>
           <a:p>
             <a:pPr algn="ctr"/>
+            <a:endParaRPr/>
           </a:p>
         </p:txBody>
       </p:sp>
@@ -17157,6 +17299,7 @@
           <a:lstStyle/>
           <a:p>
             <a:pPr algn="ctr"/>
+            <a:endParaRPr/>
           </a:p>
         </p:txBody>
       </p:sp>
@@ -17268,6 +17411,7 @@
           <a:lstStyle/>
           <a:p>
             <a:pPr algn="ctr"/>
+            <a:endParaRPr/>
           </a:p>
         </p:txBody>
       </p:sp>
@@ -17311,6 +17455,7 @@
           <a:lstStyle/>
           <a:p>
             <a:pPr algn="ctr"/>
+            <a:endParaRPr/>
           </a:p>
         </p:txBody>
       </p:sp>
@@ -17354,6 +17499,7 @@
           <a:lstStyle/>
           <a:p>
             <a:pPr algn="ctr"/>
+            <a:endParaRPr/>
           </a:p>
         </p:txBody>
       </p:sp>
@@ -17465,6 +17611,7 @@
           <a:lstStyle/>
           <a:p>
             <a:pPr algn="ctr"/>
+            <a:endParaRPr/>
           </a:p>
         </p:txBody>
       </p:sp>
@@ -17576,6 +17723,7 @@
           <a:lstStyle/>
           <a:p>
             <a:pPr algn="ctr"/>
+            <a:endParaRPr/>
           </a:p>
         </p:txBody>
       </p:sp>
@@ -17619,6 +17767,7 @@
           <a:lstStyle/>
           <a:p>
             <a:pPr algn="ctr"/>
+            <a:endParaRPr/>
           </a:p>
         </p:txBody>
       </p:sp>
@@ -17662,6 +17811,7 @@
           <a:lstStyle/>
           <a:p>
             <a:pPr algn="ctr"/>
+            <a:endParaRPr/>
           </a:p>
         </p:txBody>
       </p:sp>
@@ -17773,6 +17923,7 @@
           <a:lstStyle/>
           <a:p>
             <a:pPr algn="ctr"/>
+            <a:endParaRPr/>
           </a:p>
         </p:txBody>
       </p:sp>
@@ -17884,6 +18035,7 @@
           <a:lstStyle/>
           <a:p>
             <a:pPr algn="ctr"/>
+            <a:endParaRPr/>
           </a:p>
         </p:txBody>
       </p:sp>
@@ -17927,6 +18079,7 @@
           <a:lstStyle/>
           <a:p>
             <a:pPr algn="ctr"/>
+            <a:endParaRPr/>
           </a:p>
         </p:txBody>
       </p:sp>
@@ -17970,6 +18123,7 @@
           <a:lstStyle/>
           <a:p>
             <a:pPr algn="ctr"/>
+            <a:endParaRPr/>
           </a:p>
         </p:txBody>
       </p:sp>
@@ -18081,6 +18235,7 @@
           <a:lstStyle/>
           <a:p>
             <a:pPr algn="ctr"/>
+            <a:endParaRPr/>
           </a:p>
         </p:txBody>
       </p:sp>
@@ -18192,6 +18347,7 @@
           <a:lstStyle/>
           <a:p>
             <a:pPr algn="ctr"/>
+            <a:endParaRPr/>
           </a:p>
         </p:txBody>
       </p:sp>
@@ -18235,6 +18391,7 @@
           <a:lstStyle/>
           <a:p>
             <a:pPr algn="ctr"/>
+            <a:endParaRPr/>
           </a:p>
         </p:txBody>
       </p:sp>
@@ -18278,6 +18435,7 @@
           <a:lstStyle/>
           <a:p>
             <a:pPr algn="ctr"/>
+            <a:endParaRPr/>
           </a:p>
         </p:txBody>
       </p:sp>
@@ -18389,6 +18547,7 @@
           <a:lstStyle/>
           <a:p>
             <a:pPr algn="ctr"/>
+            <a:endParaRPr/>
           </a:p>
         </p:txBody>
       </p:sp>
@@ -18500,6 +18659,7 @@
           <a:lstStyle/>
           <a:p>
             <a:pPr algn="ctr"/>
+            <a:endParaRPr/>
           </a:p>
         </p:txBody>
       </p:sp>
@@ -18543,6 +18703,7 @@
           <a:lstStyle/>
           <a:p>
             <a:pPr algn="ctr"/>
+            <a:endParaRPr/>
           </a:p>
         </p:txBody>
       </p:sp>
@@ -18586,6 +18747,7 @@
           <a:lstStyle/>
           <a:p>
             <a:pPr algn="ctr"/>
+            <a:endParaRPr/>
           </a:p>
         </p:txBody>
       </p:sp>
@@ -18697,6 +18859,7 @@
           <a:lstStyle/>
           <a:p>
             <a:pPr algn="ctr"/>
+            <a:endParaRPr/>
           </a:p>
         </p:txBody>
       </p:sp>
@@ -18808,6 +18971,7 @@
           <a:lstStyle/>
           <a:p>
             <a:pPr algn="ctr"/>
+            <a:endParaRPr/>
           </a:p>
         </p:txBody>
       </p:sp>
@@ -18851,6 +19015,7 @@
           <a:lstStyle/>
           <a:p>
             <a:pPr algn="ctr"/>
+            <a:endParaRPr/>
           </a:p>
         </p:txBody>
       </p:sp>
@@ -18962,6 +19127,7 @@
           <a:lstStyle/>
           <a:p>
             <a:pPr algn="ctr"/>
+            <a:endParaRPr/>
           </a:p>
         </p:txBody>
       </p:sp>
@@ -19005,6 +19171,7 @@
           <a:lstStyle/>
           <a:p>
             <a:pPr algn="ctr"/>
+            <a:endParaRPr/>
           </a:p>
         </p:txBody>
       </p:sp>
@@ -19153,8 +19320,453 @@
 </p:sld>
 </file>
 
+<file path=ppt/slides/slide17.xml><?xml version="1.0" encoding="utf-8"?>
+<p:sld xmlns:a="http://schemas.openxmlformats.org/drawingml/2006/main" xmlns:r="http://schemas.openxmlformats.org/officeDocument/2006/relationships" xmlns:p="http://schemas.openxmlformats.org/presentationml/2006/main">
+  <p:cSld>
+    <p:bg>
+      <p:bgPr>
+        <a:solidFill>
+          <a:srgbClr val="050508"/>
+        </a:solidFill>
+        <a:effectLst/>
+      </p:bgPr>
+    </p:bg>
+    <p:spTree>
+      <p:nvGrpSpPr>
+        <p:cNvPr id="1" name="">
+          <a:extLst>
+            <a:ext uri="{FF2B5EF4-FFF2-40B4-BE49-F238E27FC236}">
+              <a16:creationId xmlns:a16="http://schemas.microsoft.com/office/drawing/2014/main" id="{D714D126-023E-5857-4C18-F9A3168A316C}"/>
+            </a:ext>
+          </a:extLst>
+        </p:cNvPr>
+        <p:cNvGrpSpPr/>
+        <p:nvPr/>
+      </p:nvGrpSpPr>
+      <p:grpSpPr>
+        <a:xfrm>
+          <a:off x="0" y="0"/>
+          <a:ext cx="0" cy="0"/>
+          <a:chOff x="0" y="0"/>
+          <a:chExt cx="0" cy="0"/>
+        </a:xfrm>
+      </p:grpSpPr>
+      <p:sp>
+        <p:nvSpPr>
+          <p:cNvPr id="2" name="Rectangle 1">
+            <a:extLst>
+              <a:ext uri="{FF2B5EF4-FFF2-40B4-BE49-F238E27FC236}">
+                <a16:creationId xmlns:a16="http://schemas.microsoft.com/office/drawing/2014/main" id="{CD4179A2-42A5-8AF3-67E4-E8AFD0BFC629}"/>
+              </a:ext>
+            </a:extLst>
+          </p:cNvPr>
+          <p:cNvSpPr/>
+          <p:nvPr/>
+        </p:nvSpPr>
+        <p:spPr>
+          <a:xfrm>
+            <a:off x="0" y="0"/>
+            <a:ext cx="73152" cy="6858000"/>
+          </a:xfrm>
+          <a:prstGeom prst="rect">
+            <a:avLst/>
+          </a:prstGeom>
+          <a:solidFill>
+            <a:srgbClr val="10B981"/>
+          </a:solidFill>
+          <a:ln w="12700">
+            <a:noFill/>
+          </a:ln>
+        </p:spPr>
+        <p:style>
+          <a:lnRef idx="1">
+            <a:schemeClr val="accent1"/>
+          </a:lnRef>
+          <a:fillRef idx="3">
+            <a:schemeClr val="accent1"/>
+          </a:fillRef>
+          <a:effectRef idx="2">
+            <a:schemeClr val="accent1"/>
+          </a:effectRef>
+          <a:fontRef idx="minor">
+            <a:schemeClr val="lt1"/>
+          </a:fontRef>
+        </p:style>
+        <p:txBody>
+          <a:bodyPr rtlCol="0" anchor="ctr"/>
+          <a:lstStyle/>
+          <a:p>
+            <a:pPr algn="ctr"/>
+            <a:endParaRPr/>
+          </a:p>
+        </p:txBody>
+      </p:sp>
+      <p:sp>
+        <p:nvSpPr>
+          <p:cNvPr id="3" name="TextBox 2">
+            <a:extLst>
+              <a:ext uri="{FF2B5EF4-FFF2-40B4-BE49-F238E27FC236}">
+                <a16:creationId xmlns:a16="http://schemas.microsoft.com/office/drawing/2014/main" id="{50479D4B-8548-8D7B-5AD7-47EA5671424A}"/>
+              </a:ext>
+            </a:extLst>
+          </p:cNvPr>
+          <p:cNvSpPr txBox="1"/>
+          <p:nvPr/>
+        </p:nvSpPr>
+        <p:spPr>
+          <a:xfrm>
+            <a:off x="365760" y="731520"/>
+            <a:ext cx="8229600" cy="1371600"/>
+          </a:xfrm>
+          <a:prstGeom prst="rect">
+            <a:avLst/>
+          </a:prstGeom>
+          <a:noFill/>
+        </p:spPr>
+        <p:txBody>
+          <a:bodyPr wrap="square">
+            <a:spAutoFit/>
+          </a:bodyPr>
+          <a:lstStyle/>
+          <a:p>
+            <a:pPr algn="l"/>
+            <a:r>
+              <a:rPr lang="en-IN" sz="8000" b="1" dirty="0">
+                <a:solidFill>
+                  <a:srgbClr val="FFFFFF"/>
+                </a:solidFill>
+              </a:rPr>
+              <a:t>WARDEN</a:t>
+            </a:r>
+            <a:endParaRPr sz="8000" b="1" dirty="0">
+              <a:solidFill>
+                <a:srgbClr val="FFFFFF"/>
+              </a:solidFill>
+            </a:endParaRPr>
+          </a:p>
+        </p:txBody>
+      </p:sp>
+      <p:sp>
+        <p:nvSpPr>
+          <p:cNvPr id="4" name="TextBox 3">
+            <a:extLst>
+              <a:ext uri="{FF2B5EF4-FFF2-40B4-BE49-F238E27FC236}">
+                <a16:creationId xmlns:a16="http://schemas.microsoft.com/office/drawing/2014/main" id="{A5D7B107-E19C-8E3B-2EFA-49AFB3BA2A28}"/>
+              </a:ext>
+            </a:extLst>
+          </p:cNvPr>
+          <p:cNvSpPr txBox="1"/>
+          <p:nvPr/>
+        </p:nvSpPr>
+        <p:spPr>
+          <a:xfrm>
+            <a:off x="365760" y="2148840"/>
+            <a:ext cx="9144000" cy="548640"/>
+          </a:xfrm>
+          <a:prstGeom prst="rect">
+            <a:avLst/>
+          </a:prstGeom>
+          <a:noFill/>
+        </p:spPr>
+        <p:txBody>
+          <a:bodyPr wrap="square">
+            <a:spAutoFit/>
+          </a:bodyPr>
+          <a:lstStyle/>
+          <a:p>
+            <a:pPr algn="l"/>
+            <a:r>
+              <a:rPr sz="2400" b="0">
+                <a:solidFill>
+                  <a:srgbClr val="10B981"/>
+                </a:solidFill>
+              </a:rPr>
+              <a:t>Adaptive-Compute Neural Routing Engine</a:t>
+            </a:r>
+          </a:p>
+        </p:txBody>
+      </p:sp>
+      <p:sp>
+        <p:nvSpPr>
+          <p:cNvPr id="5" name="TextBox 4">
+            <a:extLst>
+              <a:ext uri="{FF2B5EF4-FFF2-40B4-BE49-F238E27FC236}">
+                <a16:creationId xmlns:a16="http://schemas.microsoft.com/office/drawing/2014/main" id="{C4A7B680-8A90-1DFD-A659-9DD6726AA925}"/>
+              </a:ext>
+            </a:extLst>
+          </p:cNvPr>
+          <p:cNvSpPr txBox="1"/>
+          <p:nvPr/>
+        </p:nvSpPr>
+        <p:spPr>
+          <a:xfrm>
+            <a:off x="365760" y="2697480"/>
+            <a:ext cx="9144000" cy="457200"/>
+          </a:xfrm>
+          <a:prstGeom prst="rect">
+            <a:avLst/>
+          </a:prstGeom>
+          <a:noFill/>
+        </p:spPr>
+        <p:txBody>
+          <a:bodyPr wrap="square">
+            <a:spAutoFit/>
+          </a:bodyPr>
+          <a:lstStyle/>
+          <a:p>
+            <a:pPr algn="l"/>
+            <a:r>
+              <a:rPr sz="2000" b="0">
+                <a:solidFill>
+                  <a:srgbClr val="94A3B8"/>
+                </a:solidFill>
+              </a:rPr>
+              <a:t>for Enterprise LLMs on AMD ROCm™</a:t>
+            </a:r>
+          </a:p>
+        </p:txBody>
+      </p:sp>
+      <p:sp>
+        <p:nvSpPr>
+          <p:cNvPr id="6" name="Rectangle 5">
+            <a:extLst>
+              <a:ext uri="{FF2B5EF4-FFF2-40B4-BE49-F238E27FC236}">
+                <a16:creationId xmlns:a16="http://schemas.microsoft.com/office/drawing/2014/main" id="{430E5A0A-1F54-3CDE-6C54-C837EBD21B28}"/>
+              </a:ext>
+            </a:extLst>
+          </p:cNvPr>
+          <p:cNvSpPr/>
+          <p:nvPr/>
+        </p:nvSpPr>
+        <p:spPr>
+          <a:xfrm>
+            <a:off x="365760" y="3291840"/>
+            <a:ext cx="6400800" cy="38100"/>
+          </a:xfrm>
+          <a:prstGeom prst="rect">
+            <a:avLst/>
+          </a:prstGeom>
+          <a:solidFill>
+            <a:srgbClr val="10B981"/>
+          </a:solidFill>
+          <a:ln>
+            <a:noFill/>
+          </a:ln>
+        </p:spPr>
+        <p:style>
+          <a:lnRef idx="1">
+            <a:schemeClr val="accent1"/>
+          </a:lnRef>
+          <a:fillRef idx="3">
+            <a:schemeClr val="accent1"/>
+          </a:fillRef>
+          <a:effectRef idx="2">
+            <a:schemeClr val="accent1"/>
+          </a:effectRef>
+          <a:fontRef idx="minor">
+            <a:schemeClr val="lt1"/>
+          </a:fontRef>
+        </p:style>
+        <p:txBody>
+          <a:bodyPr rtlCol="0" anchor="ctr"/>
+          <a:lstStyle/>
+          <a:p>
+            <a:pPr algn="ctr"/>
+            <a:endParaRPr/>
+          </a:p>
+        </p:txBody>
+      </p:sp>
+      <p:sp>
+        <p:nvSpPr>
+          <p:cNvPr id="7" name="TextBox 6">
+            <a:extLst>
+              <a:ext uri="{FF2B5EF4-FFF2-40B4-BE49-F238E27FC236}">
+                <a16:creationId xmlns:a16="http://schemas.microsoft.com/office/drawing/2014/main" id="{8DC28172-530D-1EB5-6E3D-0DB4B4C13C1B}"/>
+              </a:ext>
+            </a:extLst>
+          </p:cNvPr>
+          <p:cNvSpPr txBox="1"/>
+          <p:nvPr/>
+        </p:nvSpPr>
+        <p:spPr>
+          <a:xfrm>
+            <a:off x="365760" y="3474720"/>
+            <a:ext cx="8229600" cy="914400"/>
+          </a:xfrm>
+          <a:prstGeom prst="rect">
+            <a:avLst/>
+          </a:prstGeom>
+          <a:noFill/>
+        </p:spPr>
+        <p:txBody>
+          <a:bodyPr wrap="square">
+            <a:spAutoFit/>
+          </a:bodyPr>
+          <a:lstStyle/>
+          <a:p>
+            <a:pPr algn="l"/>
+            <a:r>
+              <a:rPr sz="1400" b="0">
+                <a:solidFill>
+                  <a:srgbClr val="94A3B8"/>
+                </a:solidFill>
+              </a:rPr>
+              <a:t>Stops adversarial LLM traffic before it reaches your GPU.
+Five cascading security tiers. Zero false positives. Real hardware validation.</a:t>
+            </a:r>
+          </a:p>
+        </p:txBody>
+      </p:sp>
+      <p:sp>
+        <p:nvSpPr>
+          <p:cNvPr id="20" name="Rectangle 19">
+            <a:extLst>
+              <a:ext uri="{FF2B5EF4-FFF2-40B4-BE49-F238E27FC236}">
+                <a16:creationId xmlns:a16="http://schemas.microsoft.com/office/drawing/2014/main" id="{0F23005E-FDDB-1740-4B79-7E0116C47A00}"/>
+              </a:ext>
+            </a:extLst>
+          </p:cNvPr>
+          <p:cNvSpPr/>
+          <p:nvPr/>
+        </p:nvSpPr>
+        <p:spPr>
+          <a:xfrm>
+            <a:off x="9875520" y="182880"/>
+            <a:ext cx="2103120" cy="548640"/>
+          </a:xfrm>
+          <a:prstGeom prst="rect">
+            <a:avLst/>
+          </a:prstGeom>
+          <a:solidFill>
+            <a:srgbClr val="ED1C24"/>
+          </a:solidFill>
+          <a:ln w="12700">
+            <a:noFill/>
+          </a:ln>
+        </p:spPr>
+        <p:style>
+          <a:lnRef idx="1">
+            <a:schemeClr val="accent1"/>
+          </a:lnRef>
+          <a:fillRef idx="3">
+            <a:schemeClr val="accent1"/>
+          </a:fillRef>
+          <a:effectRef idx="2">
+            <a:schemeClr val="accent1"/>
+          </a:effectRef>
+          <a:fontRef idx="minor">
+            <a:schemeClr val="lt1"/>
+          </a:fontRef>
+        </p:style>
+        <p:txBody>
+          <a:bodyPr rtlCol="0" anchor="ctr"/>
+          <a:lstStyle/>
+          <a:p>
+            <a:pPr algn="ctr"/>
+            <a:endParaRPr/>
+          </a:p>
+        </p:txBody>
+      </p:sp>
+      <p:sp>
+        <p:nvSpPr>
+          <p:cNvPr id="21" name="TextBox 20">
+            <a:extLst>
+              <a:ext uri="{FF2B5EF4-FFF2-40B4-BE49-F238E27FC236}">
+                <a16:creationId xmlns:a16="http://schemas.microsoft.com/office/drawing/2014/main" id="{DB4A704F-D535-BC7B-1015-985CE29C6100}"/>
+              </a:ext>
+            </a:extLst>
+          </p:cNvPr>
+          <p:cNvSpPr txBox="1"/>
+          <p:nvPr/>
+        </p:nvSpPr>
+        <p:spPr>
+          <a:xfrm>
+            <a:off x="9921240" y="246888"/>
+            <a:ext cx="2011680" cy="411480"/>
+          </a:xfrm>
+          <a:prstGeom prst="rect">
+            <a:avLst/>
+          </a:prstGeom>
+          <a:noFill/>
+        </p:spPr>
+        <p:txBody>
+          <a:bodyPr wrap="square">
+            <a:spAutoFit/>
+          </a:bodyPr>
+          <a:lstStyle/>
+          <a:p>
+            <a:pPr algn="ctr"/>
+            <a:r>
+              <a:rPr sz="900" b="1">
+                <a:solidFill>
+                  <a:srgbClr val="FFFFFF"/>
+                </a:solidFill>
+              </a:rPr>
+              <a:t>AMD Developer Hackathon 2026</a:t>
+            </a:r>
+          </a:p>
+        </p:txBody>
+      </p:sp>
+      <p:sp>
+        <p:nvSpPr>
+          <p:cNvPr id="24" name="TextBox 23">
+            <a:extLst>
+              <a:ext uri="{FF2B5EF4-FFF2-40B4-BE49-F238E27FC236}">
+                <a16:creationId xmlns:a16="http://schemas.microsoft.com/office/drawing/2014/main" id="{9F84F0FB-A007-846E-D9B0-3D4AC4A8D7D6}"/>
+              </a:ext>
+            </a:extLst>
+          </p:cNvPr>
+          <p:cNvSpPr txBox="1"/>
+          <p:nvPr/>
+        </p:nvSpPr>
+        <p:spPr>
+          <a:xfrm>
+            <a:off x="1979612" y="4754880"/>
+            <a:ext cx="8229600" cy="1371600"/>
+          </a:xfrm>
+          <a:prstGeom prst="rect">
+            <a:avLst/>
+          </a:prstGeom>
+          <a:noFill/>
+        </p:spPr>
+        <p:txBody>
+          <a:bodyPr wrap="square">
+            <a:spAutoFit/>
+          </a:bodyPr>
+          <a:lstStyle/>
+          <a:p>
+            <a:pPr algn="ctr"/>
+            <a:r>
+              <a:rPr lang="en-US" sz="8000" b="1" dirty="0">
+                <a:solidFill>
+                  <a:srgbClr val="FFFFFF"/>
+                </a:solidFill>
+              </a:rPr>
+              <a:t>THANKYOU</a:t>
+            </a:r>
+            <a:endParaRPr sz="8000" b="1" dirty="0">
+              <a:solidFill>
+                <a:srgbClr val="FFFFFF"/>
+              </a:solidFill>
+            </a:endParaRPr>
+          </a:p>
+        </p:txBody>
+      </p:sp>
+    </p:spTree>
+    <p:extLst>
+      <p:ext uri="{BB962C8B-B14F-4D97-AF65-F5344CB8AC3E}">
+        <p14:creationId xmlns:p14="http://schemas.microsoft.com/office/powerpoint/2010/main" val="898858043"/>
+      </p:ext>
+    </p:extLst>
+  </p:cSld>
+  <p:clrMapOvr>
+    <a:masterClrMapping/>
+  </p:clrMapOvr>
+</p:sld>
+</file>
+
 <file path=ppt/slides/slide2.xml><?xml version="1.0" encoding="utf-8"?>
-<p:sld xmlns:a="http://schemas.openxmlformats.org/drawingml/2006/main" xmlns:p="http://schemas.openxmlformats.org/presentationml/2006/main" xmlns:r="http://schemas.openxmlformats.org/officeDocument/2006/relationships">
+<p:sld xmlns:a="http://schemas.openxmlformats.org/drawingml/2006/main" xmlns:r="http://schemas.openxmlformats.org/officeDocument/2006/relationships" xmlns:p="http://schemas.openxmlformats.org/presentationml/2006/main">
   <p:cSld>
     <p:bg>
       <p:bgPr>
@@ -19170,7 +19782,14 @@
         <p:cNvGrpSpPr/>
         <p:nvPr/>
       </p:nvGrpSpPr>
-      <p:grpSpPr/>
+      <p:grpSpPr>
+        <a:xfrm>
+          <a:off x="0" y="0"/>
+          <a:ext cx="0" cy="0"/>
+          <a:chOff x="0" y="0"/>
+          <a:chExt cx="0" cy="0"/>
+        </a:xfrm>
+      </p:grpSpPr>
       <p:sp>
         <p:nvSpPr>
           <p:cNvPr id="2" name="Rectangle 1"/>
@@ -19211,6 +19830,7 @@
           <a:lstStyle/>
           <a:p>
             <a:pPr algn="ctr"/>
+            <a:endParaRPr/>
           </a:p>
         </p:txBody>
       </p:sp>
@@ -19288,6 +19908,7 @@
           <a:lstStyle/>
           <a:p>
             <a:pPr algn="ctr"/>
+            <a:endParaRPr/>
           </a:p>
         </p:txBody>
       </p:sp>
@@ -19367,6 +19988,7 @@
           <a:lstStyle/>
           <a:p>
             <a:pPr algn="ctr"/>
+            <a:endParaRPr/>
           </a:p>
         </p:txBody>
       </p:sp>
@@ -19480,6 +20102,7 @@
           <a:lstStyle/>
           <a:p>
             <a:pPr algn="ctr"/>
+            <a:endParaRPr/>
           </a:p>
         </p:txBody>
       </p:sp>
@@ -19593,6 +20216,7 @@
           <a:lstStyle/>
           <a:p>
             <a:pPr algn="ctr"/>
+            <a:endParaRPr/>
           </a:p>
         </p:txBody>
       </p:sp>
@@ -19706,6 +20330,7 @@
           <a:lstStyle/>
           <a:p>
             <a:pPr algn="ctr"/>
+            <a:endParaRPr/>
           </a:p>
         </p:txBody>
       </p:sp>
@@ -19820,7 +20445,7 @@
 </file>
 
 <file path=ppt/slides/slide3.xml><?xml version="1.0" encoding="utf-8"?>
-<p:sld xmlns:a="http://schemas.openxmlformats.org/drawingml/2006/main" xmlns:p="http://schemas.openxmlformats.org/presentationml/2006/main" xmlns:r="http://schemas.openxmlformats.org/officeDocument/2006/relationships">
+<p:sld xmlns:a="http://schemas.openxmlformats.org/drawingml/2006/main" xmlns:r="http://schemas.openxmlformats.org/officeDocument/2006/relationships" xmlns:p="http://schemas.openxmlformats.org/presentationml/2006/main">
   <p:cSld>
     <p:bg>
       <p:bgPr>
@@ -19836,7 +20461,14 @@
         <p:cNvGrpSpPr/>
         <p:nvPr/>
       </p:nvGrpSpPr>
-      <p:grpSpPr/>
+      <p:grpSpPr>
+        <a:xfrm>
+          <a:off x="0" y="0"/>
+          <a:ext cx="0" cy="0"/>
+          <a:chOff x="0" y="0"/>
+          <a:chExt cx="0" cy="0"/>
+        </a:xfrm>
+      </p:grpSpPr>
       <p:sp>
         <p:nvSpPr>
           <p:cNvPr id="2" name="Rectangle 1"/>
@@ -19877,6 +20509,7 @@
           <a:lstStyle/>
           <a:p>
             <a:pPr algn="ctr"/>
+            <a:endParaRPr/>
           </a:p>
         </p:txBody>
       </p:sp>
@@ -19954,6 +20587,7 @@
           <a:lstStyle/>
           <a:p>
             <a:pPr algn="ctr"/>
+            <a:endParaRPr/>
           </a:p>
         </p:txBody>
       </p:sp>
@@ -20067,6 +20701,7 @@
           <a:lstStyle/>
           <a:p>
             <a:pPr algn="ctr"/>
+            <a:endParaRPr/>
           </a:p>
         </p:txBody>
       </p:sp>
@@ -20316,6 +20951,7 @@
           <a:lstStyle/>
           <a:p>
             <a:pPr algn="ctr"/>
+            <a:endParaRPr/>
           </a:p>
         </p:txBody>
       </p:sp>
@@ -20565,6 +21201,7 @@
           <a:lstStyle/>
           <a:p>
             <a:pPr algn="ctr"/>
+            <a:endParaRPr/>
           </a:p>
         </p:txBody>
       </p:sp>
@@ -20814,6 +21451,7 @@
           <a:lstStyle/>
           <a:p>
             <a:pPr algn="ctr"/>
+            <a:endParaRPr/>
           </a:p>
         </p:txBody>
       </p:sp>
@@ -21063,6 +21701,7 @@
           <a:lstStyle/>
           <a:p>
             <a:pPr algn="ctr"/>
+            <a:endParaRPr/>
           </a:p>
         </p:txBody>
       </p:sp>
@@ -21313,7 +21952,7 @@
 </file>
 
 <file path=ppt/slides/slide4.xml><?xml version="1.0" encoding="utf-8"?>
-<p:sld xmlns:a="http://schemas.openxmlformats.org/drawingml/2006/main" xmlns:p="http://schemas.openxmlformats.org/presentationml/2006/main" xmlns:r="http://schemas.openxmlformats.org/officeDocument/2006/relationships">
+<p:sld xmlns:a="http://schemas.openxmlformats.org/drawingml/2006/main" xmlns:r="http://schemas.openxmlformats.org/officeDocument/2006/relationships" xmlns:p="http://schemas.openxmlformats.org/presentationml/2006/main">
   <p:cSld>
     <p:bg>
       <p:bgPr>
@@ -21329,7 +21968,14 @@
         <p:cNvGrpSpPr/>
         <p:nvPr/>
       </p:nvGrpSpPr>
-      <p:grpSpPr/>
+      <p:grpSpPr>
+        <a:xfrm>
+          <a:off x="0" y="0"/>
+          <a:ext cx="0" cy="0"/>
+          <a:chOff x="0" y="0"/>
+          <a:chExt cx="0" cy="0"/>
+        </a:xfrm>
+      </p:grpSpPr>
       <p:sp>
         <p:nvSpPr>
           <p:cNvPr id="2" name="Rectangle 1"/>
@@ -21370,6 +22016,7 @@
           <a:lstStyle/>
           <a:p>
             <a:pPr algn="ctr"/>
+            <a:endParaRPr/>
           </a:p>
         </p:txBody>
       </p:sp>
@@ -21447,6 +22094,7 @@
           <a:lstStyle/>
           <a:p>
             <a:pPr algn="ctr"/>
+            <a:endParaRPr/>
           </a:p>
         </p:txBody>
       </p:sp>
@@ -21526,6 +22174,7 @@
           <a:lstStyle/>
           <a:p>
             <a:pPr algn="ctr"/>
+            <a:endParaRPr/>
           </a:p>
         </p:txBody>
       </p:sp>
@@ -21640,6 +22289,7 @@
           <a:lstStyle/>
           <a:p>
             <a:pPr algn="ctr"/>
+            <a:endParaRPr/>
           </a:p>
         </p:txBody>
       </p:sp>
@@ -21754,6 +22404,7 @@
           <a:lstStyle/>
           <a:p>
             <a:pPr algn="ctr"/>
+            <a:endParaRPr/>
           </a:p>
         </p:txBody>
       </p:sp>
@@ -21868,6 +22519,7 @@
           <a:lstStyle/>
           <a:p>
             <a:pPr algn="ctr"/>
+            <a:endParaRPr/>
           </a:p>
         </p:txBody>
       </p:sp>
@@ -22014,6 +22666,7 @@
           <a:lstStyle/>
           <a:p>
             <a:pPr algn="ctr"/>
+            <a:endParaRPr/>
           </a:p>
         </p:txBody>
       </p:sp>
@@ -22159,6 +22812,7 @@
           <a:lstStyle/>
           <a:p>
             <a:pPr algn="ctr"/>
+            <a:endParaRPr/>
           </a:p>
         </p:txBody>
       </p:sp>
@@ -22304,6 +22958,7 @@
           <a:lstStyle/>
           <a:p>
             <a:pPr algn="ctr"/>
+            <a:endParaRPr/>
           </a:p>
         </p:txBody>
       </p:sp>
@@ -22449,6 +23104,7 @@
           <a:lstStyle/>
           <a:p>
             <a:pPr algn="ctr"/>
+            <a:endParaRPr/>
           </a:p>
         </p:txBody>
       </p:sp>
@@ -22594,6 +23250,7 @@
           <a:lstStyle/>
           <a:p>
             <a:pPr algn="ctr"/>
+            <a:endParaRPr/>
           </a:p>
         </p:txBody>
       </p:sp>
@@ -22739,6 +23396,7 @@
           <a:lstStyle/>
           <a:p>
             <a:pPr algn="ctr"/>
+            <a:endParaRPr/>
           </a:p>
         </p:txBody>
       </p:sp>
@@ -22884,6 +23542,7 @@
           <a:lstStyle/>
           <a:p>
             <a:pPr algn="ctr"/>
+            <a:endParaRPr/>
           </a:p>
         </p:txBody>
       </p:sp>
@@ -23029,6 +23688,7 @@
           <a:lstStyle/>
           <a:p>
             <a:pPr algn="ctr"/>
+            <a:endParaRPr/>
           </a:p>
         </p:txBody>
       </p:sp>
@@ -23174,6 +23834,7 @@
           <a:lstStyle/>
           <a:p>
             <a:pPr algn="ctr"/>
+            <a:endParaRPr/>
           </a:p>
         </p:txBody>
       </p:sp>
@@ -23319,6 +23980,7 @@
           <a:lstStyle/>
           <a:p>
             <a:pPr algn="ctr"/>
+            <a:endParaRPr/>
           </a:p>
         </p:txBody>
       </p:sp>
@@ -23535,7 +24197,7 @@
 </file>
 
 <file path=ppt/slides/slide5.xml><?xml version="1.0" encoding="utf-8"?>
-<p:sld xmlns:a="http://schemas.openxmlformats.org/drawingml/2006/main" xmlns:p="http://schemas.openxmlformats.org/presentationml/2006/main" xmlns:r="http://schemas.openxmlformats.org/officeDocument/2006/relationships">
+<p:sld xmlns:a="http://schemas.openxmlformats.org/drawingml/2006/main" xmlns:r="http://schemas.openxmlformats.org/officeDocument/2006/relationships" xmlns:p="http://schemas.openxmlformats.org/presentationml/2006/main">
   <p:cSld>
     <p:bg>
       <p:bgPr>
@@ -23551,7 +24213,14 @@
         <p:cNvGrpSpPr/>
         <p:nvPr/>
       </p:nvGrpSpPr>
-      <p:grpSpPr/>
+      <p:grpSpPr>
+        <a:xfrm>
+          <a:off x="0" y="0"/>
+          <a:ext cx="0" cy="0"/>
+          <a:chOff x="0" y="0"/>
+          <a:chExt cx="0" cy="0"/>
+        </a:xfrm>
+      </p:grpSpPr>
       <p:sp>
         <p:nvSpPr>
           <p:cNvPr id="2" name="Rectangle 1"/>
@@ -23592,6 +24261,7 @@
           <a:lstStyle/>
           <a:p>
             <a:pPr algn="ctr"/>
+            <a:endParaRPr/>
           </a:p>
         </p:txBody>
       </p:sp>
@@ -23669,6 +24339,7 @@
           <a:lstStyle/>
           <a:p>
             <a:pPr algn="ctr"/>
+            <a:endParaRPr/>
           </a:p>
         </p:txBody>
       </p:sp>
@@ -23748,6 +24419,7 @@
           <a:lstStyle/>
           <a:p>
             <a:pPr algn="ctr"/>
+            <a:endParaRPr/>
           </a:p>
         </p:txBody>
       </p:sp>
@@ -23791,6 +24463,7 @@
           <a:lstStyle/>
           <a:p>
             <a:pPr algn="ctr"/>
+            <a:endParaRPr/>
           </a:p>
         </p:txBody>
       </p:sp>
@@ -23938,6 +24611,7 @@
           <a:lstStyle/>
           <a:p>
             <a:pPr algn="ctr"/>
+            <a:endParaRPr/>
           </a:p>
         </p:txBody>
       </p:sp>
@@ -23981,6 +24655,7 @@
           <a:lstStyle/>
           <a:p>
             <a:pPr algn="ctr"/>
+            <a:endParaRPr/>
           </a:p>
         </p:txBody>
       </p:sp>
@@ -24128,6 +24803,7 @@
           <a:lstStyle/>
           <a:p>
             <a:pPr algn="ctr"/>
+            <a:endParaRPr/>
           </a:p>
         </p:txBody>
       </p:sp>
@@ -24171,6 +24847,7 @@
           <a:lstStyle/>
           <a:p>
             <a:pPr algn="ctr"/>
+            <a:endParaRPr/>
           </a:p>
         </p:txBody>
       </p:sp>
@@ -24318,6 +24995,7 @@
           <a:lstStyle/>
           <a:p>
             <a:pPr algn="ctr"/>
+            <a:endParaRPr/>
           </a:p>
         </p:txBody>
       </p:sp>
@@ -24361,6 +25039,7 @@
           <a:lstStyle/>
           <a:p>
             <a:pPr algn="ctr"/>
+            <a:endParaRPr/>
           </a:p>
         </p:txBody>
       </p:sp>
@@ -24508,6 +25187,7 @@
           <a:lstStyle/>
           <a:p>
             <a:pPr algn="ctr"/>
+            <a:endParaRPr/>
           </a:p>
         </p:txBody>
       </p:sp>
@@ -24551,6 +25231,7 @@
           <a:lstStyle/>
           <a:p>
             <a:pPr algn="ctr"/>
+            <a:endParaRPr/>
           </a:p>
         </p:txBody>
       </p:sp>
@@ -24698,6 +25379,7 @@
           <a:lstStyle/>
           <a:p>
             <a:pPr algn="ctr"/>
+            <a:endParaRPr/>
           </a:p>
         </p:txBody>
       </p:sp>
@@ -24741,6 +25423,7 @@
           <a:lstStyle/>
           <a:p>
             <a:pPr algn="ctr"/>
+            <a:endParaRPr/>
           </a:p>
         </p:txBody>
       </p:sp>
@@ -24888,6 +25571,7 @@
           <a:lstStyle/>
           <a:p>
             <a:pPr algn="ctr"/>
+            <a:endParaRPr/>
           </a:p>
         </p:txBody>
       </p:sp>
@@ -24931,6 +25615,7 @@
           <a:lstStyle/>
           <a:p>
             <a:pPr algn="ctr"/>
+            <a:endParaRPr/>
           </a:p>
         </p:txBody>
       </p:sp>
@@ -25078,6 +25763,7 @@
           <a:lstStyle/>
           <a:p>
             <a:pPr algn="ctr"/>
+            <a:endParaRPr/>
           </a:p>
         </p:txBody>
       </p:sp>
@@ -25121,6 +25807,7 @@
           <a:lstStyle/>
           <a:p>
             <a:pPr algn="ctr"/>
+            <a:endParaRPr/>
           </a:p>
         </p:txBody>
       </p:sp>
@@ -25235,7 +25922,7 @@
 </file>
 
 <file path=ppt/slides/slide6.xml><?xml version="1.0" encoding="utf-8"?>
-<p:sld xmlns:a="http://schemas.openxmlformats.org/drawingml/2006/main" xmlns:p="http://schemas.openxmlformats.org/presentationml/2006/main" xmlns:r="http://schemas.openxmlformats.org/officeDocument/2006/relationships">
+<p:sld xmlns:a="http://schemas.openxmlformats.org/drawingml/2006/main" xmlns:r="http://schemas.openxmlformats.org/officeDocument/2006/relationships" xmlns:p="http://schemas.openxmlformats.org/presentationml/2006/main">
   <p:cSld>
     <p:bg>
       <p:bgPr>
@@ -25251,7 +25938,14 @@
         <p:cNvGrpSpPr/>
         <p:nvPr/>
       </p:nvGrpSpPr>
-      <p:grpSpPr/>
+      <p:grpSpPr>
+        <a:xfrm>
+          <a:off x="0" y="0"/>
+          <a:ext cx="0" cy="0"/>
+          <a:chOff x="0" y="0"/>
+          <a:chExt cx="0" cy="0"/>
+        </a:xfrm>
+      </p:grpSpPr>
       <p:sp>
         <p:nvSpPr>
           <p:cNvPr id="2" name="Rectangle 1"/>
@@ -25292,6 +25986,7 @@
           <a:lstStyle/>
           <a:p>
             <a:pPr algn="ctr"/>
+            <a:endParaRPr/>
           </a:p>
         </p:txBody>
       </p:sp>
@@ -25369,6 +26064,7 @@
           <a:lstStyle/>
           <a:p>
             <a:pPr algn="ctr"/>
+            <a:endParaRPr/>
           </a:p>
         </p:txBody>
       </p:sp>
@@ -25448,6 +26144,7 @@
           <a:lstStyle/>
           <a:p>
             <a:pPr algn="ctr"/>
+            <a:endParaRPr/>
           </a:p>
         </p:txBody>
       </p:sp>
@@ -25525,6 +26222,7 @@
           <a:lstStyle/>
           <a:p>
             <a:pPr algn="ctr"/>
+            <a:endParaRPr/>
           </a:p>
         </p:txBody>
       </p:sp>
@@ -25636,6 +26334,7 @@
           <a:lstStyle/>
           <a:p>
             <a:pPr algn="ctr"/>
+            <a:endParaRPr/>
           </a:p>
         </p:txBody>
       </p:sp>
@@ -25747,6 +26446,7 @@
           <a:lstStyle/>
           <a:p>
             <a:pPr algn="ctr"/>
+            <a:endParaRPr/>
           </a:p>
         </p:txBody>
       </p:sp>
@@ -25858,6 +26558,7 @@
           <a:lstStyle/>
           <a:p>
             <a:pPr algn="ctr"/>
+            <a:endParaRPr/>
           </a:p>
         </p:txBody>
       </p:sp>
@@ -25969,6 +26670,7 @@
           <a:lstStyle/>
           <a:p>
             <a:pPr algn="ctr"/>
+            <a:endParaRPr/>
           </a:p>
         </p:txBody>
       </p:sp>
@@ -26080,6 +26782,7 @@
           <a:lstStyle/>
           <a:p>
             <a:pPr algn="ctr"/>
+            <a:endParaRPr/>
           </a:p>
         </p:txBody>
       </p:sp>
@@ -26193,6 +26896,7 @@
           <a:lstStyle/>
           <a:p>
             <a:pPr algn="ctr"/>
+            <a:endParaRPr/>
           </a:p>
         </p:txBody>
       </p:sp>
@@ -26270,6 +26974,7 @@
           <a:lstStyle/>
           <a:p>
             <a:pPr algn="ctr"/>
+            <a:endParaRPr/>
           </a:p>
         </p:txBody>
       </p:sp>
@@ -26381,6 +27086,7 @@
           <a:lstStyle/>
           <a:p>
             <a:pPr algn="ctr"/>
+            <a:endParaRPr/>
           </a:p>
         </p:txBody>
       </p:sp>
@@ -26492,6 +27198,7 @@
           <a:lstStyle/>
           <a:p>
             <a:pPr algn="ctr"/>
+            <a:endParaRPr/>
           </a:p>
         </p:txBody>
       </p:sp>
@@ -26603,6 +27310,7 @@
           <a:lstStyle/>
           <a:p>
             <a:pPr algn="ctr"/>
+            <a:endParaRPr/>
           </a:p>
         </p:txBody>
       </p:sp>
@@ -26714,6 +27422,7 @@
           <a:lstStyle/>
           <a:p>
             <a:pPr algn="ctr"/>
+            <a:endParaRPr/>
           </a:p>
         </p:txBody>
       </p:sp>
@@ -26825,6 +27534,7 @@
           <a:lstStyle/>
           <a:p>
             <a:pPr algn="ctr"/>
+            <a:endParaRPr/>
           </a:p>
         </p:txBody>
       </p:sp>
@@ -26905,7 +27615,7 @@
 </file>
 
 <file path=ppt/slides/slide7.xml><?xml version="1.0" encoding="utf-8"?>
-<p:sld xmlns:a="http://schemas.openxmlformats.org/drawingml/2006/main" xmlns:p="http://schemas.openxmlformats.org/presentationml/2006/main" xmlns:r="http://schemas.openxmlformats.org/officeDocument/2006/relationships">
+<p:sld xmlns:a="http://schemas.openxmlformats.org/drawingml/2006/main" xmlns:r="http://schemas.openxmlformats.org/officeDocument/2006/relationships" xmlns:p="http://schemas.openxmlformats.org/presentationml/2006/main">
   <p:cSld>
     <p:bg>
       <p:bgPr>
@@ -26921,7 +27631,14 @@
         <p:cNvGrpSpPr/>
         <p:nvPr/>
       </p:nvGrpSpPr>
-      <p:grpSpPr/>
+      <p:grpSpPr>
+        <a:xfrm>
+          <a:off x="0" y="0"/>
+          <a:ext cx="0" cy="0"/>
+          <a:chOff x="0" y="0"/>
+          <a:chExt cx="0" cy="0"/>
+        </a:xfrm>
+      </p:grpSpPr>
       <p:sp>
         <p:nvSpPr>
           <p:cNvPr id="2" name="Rectangle 1"/>
@@ -26962,6 +27679,7 @@
           <a:lstStyle/>
           <a:p>
             <a:pPr algn="ctr"/>
+            <a:endParaRPr/>
           </a:p>
         </p:txBody>
       </p:sp>
@@ -27039,6 +27757,7 @@
           <a:lstStyle/>
           <a:p>
             <a:pPr algn="ctr"/>
+            <a:endParaRPr/>
           </a:p>
         </p:txBody>
       </p:sp>
@@ -27118,6 +27837,7 @@
           <a:lstStyle/>
           <a:p>
             <a:pPr algn="ctr"/>
+            <a:endParaRPr/>
           </a:p>
         </p:txBody>
       </p:sp>
@@ -27195,6 +27915,7 @@
           <a:lstStyle/>
           <a:p>
             <a:pPr algn="ctr"/>
+            <a:endParaRPr/>
           </a:p>
         </p:txBody>
       </p:sp>
@@ -27306,6 +28027,7 @@
           <a:lstStyle/>
           <a:p>
             <a:pPr algn="ctr"/>
+            <a:endParaRPr/>
           </a:p>
         </p:txBody>
       </p:sp>
@@ -27417,6 +28139,7 @@
           <a:lstStyle/>
           <a:p>
             <a:pPr algn="ctr"/>
+            <a:endParaRPr/>
           </a:p>
         </p:txBody>
       </p:sp>
@@ -27528,6 +28251,7 @@
           <a:lstStyle/>
           <a:p>
             <a:pPr algn="ctr"/>
+            <a:endParaRPr/>
           </a:p>
         </p:txBody>
       </p:sp>
@@ -27639,6 +28363,7 @@
           <a:lstStyle/>
           <a:p>
             <a:pPr algn="ctr"/>
+            <a:endParaRPr/>
           </a:p>
         </p:txBody>
       </p:sp>
@@ -27752,6 +28477,7 @@
           <a:lstStyle/>
           <a:p>
             <a:pPr algn="ctr"/>
+            <a:endParaRPr/>
           </a:p>
         </p:txBody>
       </p:sp>
@@ -27829,6 +28555,7 @@
           <a:lstStyle/>
           <a:p>
             <a:pPr algn="ctr"/>
+            <a:endParaRPr/>
           </a:p>
         </p:txBody>
       </p:sp>
@@ -27940,6 +28667,7 @@
           <a:lstStyle/>
           <a:p>
             <a:pPr algn="ctr"/>
+            <a:endParaRPr/>
           </a:p>
         </p:txBody>
       </p:sp>
@@ -28051,6 +28779,7 @@
           <a:lstStyle/>
           <a:p>
             <a:pPr algn="ctr"/>
+            <a:endParaRPr/>
           </a:p>
         </p:txBody>
       </p:sp>
@@ -28162,6 +28891,7 @@
           <a:lstStyle/>
           <a:p>
             <a:pPr algn="ctr"/>
+            <a:endParaRPr/>
           </a:p>
         </p:txBody>
       </p:sp>
@@ -28273,6 +29003,7 @@
           <a:lstStyle/>
           <a:p>
             <a:pPr algn="ctr"/>
+            <a:endParaRPr/>
           </a:p>
         </p:txBody>
       </p:sp>
@@ -28353,7 +29084,7 @@
 </file>
 
 <file path=ppt/slides/slide8.xml><?xml version="1.0" encoding="utf-8"?>
-<p:sld xmlns:a="http://schemas.openxmlformats.org/drawingml/2006/main" xmlns:p="http://schemas.openxmlformats.org/presentationml/2006/main" xmlns:r="http://schemas.openxmlformats.org/officeDocument/2006/relationships">
+<p:sld xmlns:a="http://schemas.openxmlformats.org/drawingml/2006/main" xmlns:r="http://schemas.openxmlformats.org/officeDocument/2006/relationships" xmlns:p="http://schemas.openxmlformats.org/presentationml/2006/main">
   <p:cSld>
     <p:bg>
       <p:bgPr>
@@ -28369,7 +29100,14 @@
         <p:cNvGrpSpPr/>
         <p:nvPr/>
       </p:nvGrpSpPr>
-      <p:grpSpPr/>
+      <p:grpSpPr>
+        <a:xfrm>
+          <a:off x="0" y="0"/>
+          <a:ext cx="0" cy="0"/>
+          <a:chOff x="0" y="0"/>
+          <a:chExt cx="0" cy="0"/>
+        </a:xfrm>
+      </p:grpSpPr>
       <p:sp>
         <p:nvSpPr>
           <p:cNvPr id="2" name="Rectangle 1"/>
@@ -28410,6 +29148,7 @@
           <a:lstStyle/>
           <a:p>
             <a:pPr algn="ctr"/>
+            <a:endParaRPr/>
           </a:p>
         </p:txBody>
       </p:sp>
@@ -28487,6 +29226,7 @@
           <a:lstStyle/>
           <a:p>
             <a:pPr algn="ctr"/>
+            <a:endParaRPr/>
           </a:p>
         </p:txBody>
       </p:sp>
@@ -28566,6 +29306,7 @@
           <a:lstStyle/>
           <a:p>
             <a:pPr algn="ctr"/>
+            <a:endParaRPr/>
           </a:p>
         </p:txBody>
       </p:sp>
@@ -28679,6 +29420,7 @@
           <a:lstStyle/>
           <a:p>
             <a:pPr algn="ctr"/>
+            <a:endParaRPr/>
           </a:p>
         </p:txBody>
       </p:sp>
@@ -28792,6 +29534,7 @@
           <a:lstStyle/>
           <a:p>
             <a:pPr algn="ctr"/>
+            <a:endParaRPr/>
           </a:p>
         </p:txBody>
       </p:sp>
@@ -28905,6 +29648,7 @@
           <a:lstStyle/>
           <a:p>
             <a:pPr algn="ctr"/>
+            <a:endParaRPr/>
           </a:p>
         </p:txBody>
       </p:sp>
@@ -29018,6 +29762,7 @@
           <a:lstStyle/>
           <a:p>
             <a:pPr algn="ctr"/>
+            <a:endParaRPr/>
           </a:p>
         </p:txBody>
       </p:sp>
@@ -29131,6 +29876,7 @@
           <a:lstStyle/>
           <a:p>
             <a:pPr algn="ctr"/>
+            <a:endParaRPr/>
           </a:p>
         </p:txBody>
       </p:sp>
@@ -29244,6 +29990,7 @@
           <a:lstStyle/>
           <a:p>
             <a:pPr algn="ctr"/>
+            <a:endParaRPr/>
           </a:p>
         </p:txBody>
       </p:sp>
@@ -29357,6 +30104,7 @@
           <a:lstStyle/>
           <a:p>
             <a:pPr algn="ctr"/>
+            <a:endParaRPr/>
           </a:p>
         </p:txBody>
       </p:sp>
@@ -29470,6 +30218,7 @@
           <a:lstStyle/>
           <a:p>
             <a:pPr algn="ctr"/>
+            <a:endParaRPr/>
           </a:p>
         </p:txBody>
       </p:sp>
@@ -29583,6 +30332,7 @@
           <a:lstStyle/>
           <a:p>
             <a:pPr algn="ctr"/>
+            <a:endParaRPr/>
           </a:p>
         </p:txBody>
       </p:sp>
@@ -29663,7 +30413,7 @@
 </file>
 
 <file path=ppt/slides/slide9.xml><?xml version="1.0" encoding="utf-8"?>
-<p:sld xmlns:a="http://schemas.openxmlformats.org/drawingml/2006/main" xmlns:p="http://schemas.openxmlformats.org/presentationml/2006/main" xmlns:r="http://schemas.openxmlformats.org/officeDocument/2006/relationships">
+<p:sld xmlns:a="http://schemas.openxmlformats.org/drawingml/2006/main" xmlns:r="http://schemas.openxmlformats.org/officeDocument/2006/relationships" xmlns:p="http://schemas.openxmlformats.org/presentationml/2006/main">
   <p:cSld>
     <p:bg>
       <p:bgPr>
@@ -29679,7 +30429,14 @@
         <p:cNvGrpSpPr/>
         <p:nvPr/>
       </p:nvGrpSpPr>
-      <p:grpSpPr/>
+      <p:grpSpPr>
+        <a:xfrm>
+          <a:off x="0" y="0"/>
+          <a:ext cx="0" cy="0"/>
+          <a:chOff x="0" y="0"/>
+          <a:chExt cx="0" cy="0"/>
+        </a:xfrm>
+      </p:grpSpPr>
       <p:sp>
         <p:nvSpPr>
           <p:cNvPr id="2" name="Rectangle 1"/>
@@ -29720,6 +30477,7 @@
           <a:lstStyle/>
           <a:p>
             <a:pPr algn="ctr"/>
+            <a:endParaRPr/>
           </a:p>
         </p:txBody>
       </p:sp>
@@ -29797,6 +30555,7 @@
           <a:lstStyle/>
           <a:p>
             <a:pPr algn="ctr"/>
+            <a:endParaRPr/>
           </a:p>
         </p:txBody>
       </p:sp>
@@ -29876,6 +30635,7 @@
           <a:lstStyle/>
           <a:p>
             <a:pPr algn="ctr"/>
+            <a:endParaRPr/>
           </a:p>
         </p:txBody>
       </p:sp>
@@ -29955,6 +30715,7 @@
           <a:lstStyle/>
           <a:p>
             <a:pPr algn="ctr"/>
+            <a:endParaRPr/>
           </a:p>
         </p:txBody>
       </p:sp>
@@ -30034,6 +30795,7 @@
           <a:lstStyle/>
           <a:p>
             <a:pPr algn="ctr"/>
+            <a:endParaRPr/>
           </a:p>
         </p:txBody>
       </p:sp>
@@ -30113,6 +30875,7 @@
           <a:lstStyle/>
           <a:p>
             <a:pPr algn="ctr"/>
+            <a:endParaRPr/>
           </a:p>
         </p:txBody>
       </p:sp>
@@ -30192,6 +30955,7 @@
           <a:lstStyle/>
           <a:p>
             <a:pPr algn="ctr"/>
+            <a:endParaRPr/>
           </a:p>
         </p:txBody>
       </p:sp>
@@ -30271,6 +31035,7 @@
           <a:lstStyle/>
           <a:p>
             <a:pPr algn="ctr"/>
+            <a:endParaRPr/>
           </a:p>
         </p:txBody>
       </p:sp>
@@ -30350,6 +31115,7 @@
           <a:lstStyle/>
           <a:p>
             <a:pPr algn="ctr"/>
+            <a:endParaRPr/>
           </a:p>
         </p:txBody>
       </p:sp>
@@ -30429,6 +31195,7 @@
           <a:lstStyle/>
           <a:p>
             <a:pPr algn="ctr"/>
+            <a:endParaRPr/>
           </a:p>
         </p:txBody>
       </p:sp>
@@ -30508,6 +31275,7 @@
           <a:lstStyle/>
           <a:p>
             <a:pPr algn="ctr"/>
+            <a:endParaRPr/>
           </a:p>
         </p:txBody>
       </p:sp>
@@ -30587,6 +31355,7 @@
           <a:lstStyle/>
           <a:p>
             <a:pPr algn="ctr"/>
+            <a:endParaRPr/>
           </a:p>
         </p:txBody>
       </p:sp>
@@ -30666,6 +31435,7 @@
           <a:lstStyle/>
           <a:p>
             <a:pPr algn="ctr"/>
+            <a:endParaRPr/>
           </a:p>
         </p:txBody>
       </p:sp>
@@ -30745,6 +31515,7 @@
           <a:lstStyle/>
           <a:p>
             <a:pPr algn="ctr"/>
+            <a:endParaRPr/>
           </a:p>
         </p:txBody>
       </p:sp>

</xml_diff>